<commit_message>
Align conclusions with locked TALLIP evidence
</commit_message>
<xml_diff>
--- a/docs/KD_ablation_final_20260713.pptx
+++ b/docs/KD_ablation_final_20260713.pptx
@@ -3279,7 +3279,7 @@
                 </a:solidFill>
                 <a:latin typeface="Segoe UI"/>
               </a:rPr>
-              <a:t>Final ablation synthesis · frozen submission · 2026-07-13</a:t>
+              <a:t>TALLIP evidence closure · clean-inductive + official test · 2026-07-18</a:t>
             </a:r>
           </a:p>
         </p:txBody>
@@ -3340,7 +3340,7 @@
                 </a:solidFill>
                 <a:latin typeface="Segoe UI"/>
               </a:rPr>
-              <a:t>KD EXPERIMENTS</a:t>
+              <a:t>OFFICIAL TEST · PRE-LOCKED</a:t>
             </a:r>
           </a:p>
         </p:txBody>
@@ -3375,7 +3375,7 @@
                 </a:solidFill>
                 <a:latin typeface="Segoe UI"/>
               </a:rPr>
-              <a:t>All 8 Datasets, Simplified</a:t>
+              <a:t>Four Supported KD Gains; One Inconclusive</a:t>
             </a:r>
           </a:p>
         </p:txBody>
@@ -3388,7 +3388,7 @@
         </p:nvSpPr>
         <p:spPr>
           <a:xfrm>
-            <a:off x="475488" y="1481328"/>
+            <a:off x="475488" y="1664208"/>
             <a:ext cx="11155680" cy="384048"/>
           </a:xfrm>
           <a:prstGeom prst="roundRect">
@@ -3434,8 +3434,8 @@
         </p:nvSpPr>
         <p:spPr>
           <a:xfrm>
-            <a:off x="548640" y="1517904"/>
-            <a:ext cx="1362456" cy="310896"/>
+            <a:off x="548640" y="1700784"/>
+            <a:ext cx="1773936" cy="310896"/>
           </a:xfrm>
           <a:prstGeom prst="rect">
             <a:avLst/>
@@ -3469,8 +3469,8 @@
         </p:nvSpPr>
         <p:spPr>
           <a:xfrm>
-            <a:off x="2057400" y="1517904"/>
-            <a:ext cx="1179576" cy="310896"/>
+            <a:off x="2468880" y="1700784"/>
+            <a:ext cx="1271016" cy="310896"/>
           </a:xfrm>
           <a:prstGeom prst="rect">
             <a:avLst/>
@@ -3491,7 +3491,7 @@
                 </a:solidFill>
                 <a:latin typeface="Segoe UI"/>
               </a:rPr>
-              <a:t>TEACHER</a:t>
+              <a:t>KD</a:t>
             </a:r>
           </a:p>
         </p:txBody>
@@ -3504,8 +3504,8 @@
         </p:nvSpPr>
         <p:spPr>
           <a:xfrm>
-            <a:off x="3383280" y="1517904"/>
-            <a:ext cx="3054096" cy="310896"/>
+            <a:off x="3886200" y="1700784"/>
+            <a:ext cx="1271016" cy="310896"/>
           </a:xfrm>
           <a:prstGeom prst="rect">
             <a:avLst/>
@@ -3526,7 +3526,7 @@
                 </a:solidFill>
                 <a:latin typeface="Segoe UI"/>
               </a:rPr>
-              <a:t>SILVER SOURCE</a:t>
+              <a:t>NO-KD</a:t>
             </a:r>
           </a:p>
         </p:txBody>
@@ -3539,8 +3539,8 @@
         </p:nvSpPr>
         <p:spPr>
           <a:xfrm>
-            <a:off x="6583680" y="1517904"/>
-            <a:ext cx="996696" cy="310896"/>
+            <a:off x="5303520" y="1700784"/>
+            <a:ext cx="1225296" cy="310896"/>
           </a:xfrm>
           <a:prstGeom prst="rect">
             <a:avLst/>
@@ -3561,7 +3561,7 @@
                 </a:solidFill>
                 <a:latin typeface="Segoe UI"/>
               </a:rPr>
-              <a:t>BASELINE</a:t>
+              <a:t>Δ cF1</a:t>
             </a:r>
           </a:p>
         </p:txBody>
@@ -3574,8 +3574,8 @@
         </p:nvSpPr>
         <p:spPr>
           <a:xfrm>
-            <a:off x="7726680" y="1517904"/>
-            <a:ext cx="1271016" cy="310896"/>
+            <a:off x="6675120" y="1700784"/>
+            <a:ext cx="2962656" cy="310896"/>
           </a:xfrm>
           <a:prstGeom prst="rect">
             <a:avLst/>
@@ -3596,7 +3596,7 @@
                 </a:solidFill>
                 <a:latin typeface="Segoe UI"/>
               </a:rPr>
-              <a:t>BEST KD</a:t>
+              <a:t>95% CI</a:t>
             </a:r>
           </a:p>
         </p:txBody>
@@ -3609,8 +3609,8 @@
         </p:nvSpPr>
         <p:spPr>
           <a:xfrm>
-            <a:off x="9144000" y="1517904"/>
-            <a:ext cx="1179576" cy="310896"/>
+            <a:off x="9784080" y="1700784"/>
+            <a:ext cx="1773936" cy="310896"/>
           </a:xfrm>
           <a:prstGeom prst="rect">
             <a:avLst/>
@@ -3631,56 +3631,21 @@
                 </a:solidFill>
                 <a:latin typeface="Segoe UI"/>
               </a:rPr>
-              <a:t>Δ</a:t>
-            </a:r>
-          </a:p>
-        </p:txBody>
-      </p:sp>
-      <p:sp>
-        <p:nvSpPr>
-          <p:cNvPr id="11" name="TextBox 10"/>
-          <p:cNvSpPr txBox="1"/>
-          <p:nvPr/>
-        </p:nvSpPr>
-        <p:spPr>
-          <a:xfrm>
-            <a:off x="10469880" y="1517904"/>
-            <a:ext cx="1088136" cy="310896"/>
-          </a:xfrm>
-          <a:prstGeom prst="rect">
-            <a:avLst/>
-          </a:prstGeom>
-          <a:noFill/>
-        </p:spPr>
-        <p:txBody>
-          <a:bodyPr wrap="square" lIns="0" rIns="0" tIns="25400" bIns="25400">
-            <a:spAutoFit/>
-          </a:bodyPr>
-          <a:lstStyle/>
-          <a:p>
-            <a:pPr algn="ctr"/>
-            <a:r>
-              <a:rPr sz="1150" b="1" i="0" spc="30">
-                <a:solidFill>
-                  <a:srgbClr val="64748B"/>
-                </a:solidFill>
-                <a:latin typeface="Segoe UI"/>
-              </a:rPr>
-              <a:t>ADOPTED</a:t>
-            </a:r>
-          </a:p>
-        </p:txBody>
-      </p:sp>
-      <p:sp>
-        <p:nvSpPr>
-          <p:cNvPr id="12" name="Rounded Rectangle 11"/>
+              <a:t>DECISION</a:t>
+            </a:r>
+          </a:p>
+        </p:txBody>
+      </p:sp>
+      <p:sp>
+        <p:nvSpPr>
+          <p:cNvPr id="11" name="Rounded Rectangle 10"/>
           <p:cNvSpPr/>
           <p:nvPr/>
         </p:nvSpPr>
         <p:spPr>
           <a:xfrm>
-            <a:off x="475488" y="1865376"/>
-            <a:ext cx="11155680" cy="475488"/>
+            <a:off x="475488" y="2048256"/>
+            <a:ext cx="11155680" cy="640080"/>
           </a:xfrm>
           <a:prstGeom prst="roundRect">
             <a:avLst>
@@ -3721,14 +3686,49 @@
       </p:sp>
       <p:sp>
         <p:nvSpPr>
+          <p:cNvPr id="12" name="TextBox 11"/>
+          <p:cNvSpPr txBox="1"/>
+          <p:nvPr/>
+        </p:nvSpPr>
+        <p:spPr>
+          <a:xfrm>
+            <a:off x="566928" y="2048256"/>
+            <a:ext cx="1737360" cy="640080"/>
+          </a:xfrm>
+          <a:prstGeom prst="rect">
+            <a:avLst/>
+          </a:prstGeom>
+          <a:noFill/>
+        </p:spPr>
+        <p:txBody>
+          <a:bodyPr wrap="square" anchor="ctr" lIns="0" rIns="0" tIns="25400" bIns="25400">
+            <a:spAutoFit/>
+          </a:bodyPr>
+          <a:lstStyle/>
+          <a:p>
+            <a:pPr algn="ctr"/>
+            <a:r>
+              <a:rPr sz="1300" b="1" i="0">
+                <a:solidFill>
+                  <a:srgbClr val="0F172A"/>
+                </a:solidFill>
+                <a:latin typeface="Segoe UI"/>
+              </a:rPr>
+              <a:t>eng_laptop</a:t>
+            </a:r>
+          </a:p>
+        </p:txBody>
+      </p:sp>
+      <p:sp>
+        <p:nvSpPr>
           <p:cNvPr id="13" name="TextBox 12"/>
           <p:cNvSpPr txBox="1"/>
           <p:nvPr/>
         </p:nvSpPr>
         <p:spPr>
           <a:xfrm>
-            <a:off x="566928" y="1865376"/>
-            <a:ext cx="1325880" cy="475488"/>
+            <a:off x="2487168" y="2048256"/>
+            <a:ext cx="1234440" cy="640080"/>
           </a:xfrm>
           <a:prstGeom prst="rect">
             <a:avLst/>
@@ -3743,13 +3743,13 @@
           <a:p>
             <a:pPr algn="ctr"/>
             <a:r>
-              <a:rPr sz="1150" b="1" i="0">
-                <a:solidFill>
-                  <a:srgbClr val="0F172A"/>
-                </a:solidFill>
-                <a:latin typeface="Segoe UI"/>
-              </a:rPr>
-              <a:t>eng_laptop</a:t>
+              <a:rPr sz="1300" b="0" i="0">
+                <a:solidFill>
+                  <a:srgbClr val="334155"/>
+                </a:solidFill>
+                <a:latin typeface="Segoe UI"/>
+              </a:rPr>
+              <a:t>0.3532</a:t>
             </a:r>
           </a:p>
         </p:txBody>
@@ -3762,8 +3762,8 @@
         </p:nvSpPr>
         <p:spPr>
           <a:xfrm>
-            <a:off x="2075688" y="1865376"/>
-            <a:ext cx="1143000" cy="475488"/>
+            <a:off x="3904487" y="2048256"/>
+            <a:ext cx="1234440" cy="640080"/>
           </a:xfrm>
           <a:prstGeom prst="rect">
             <a:avLst/>
@@ -3776,15 +3776,15 @@
           </a:bodyPr>
           <a:lstStyle/>
           <a:p>
-            <a:pPr algn="ctr"/>
-            <a:r>
-              <a:rPr sz="1150" b="0" i="0">
+            <a:pPr algn="l"/>
+            <a:r>
+              <a:rPr sz="1300" b="0" i="0">
                 <a:solidFill>
                   <a:srgbClr val="334155"/>
                 </a:solidFill>
                 <a:latin typeface="Segoe UI"/>
               </a:rPr>
-              <a:t>DeepSeek</a:t>
+              <a:t>0.2710</a:t>
             </a:r>
           </a:p>
         </p:txBody>
@@ -3797,8 +3797,8 @@
         </p:nvSpPr>
         <p:spPr>
           <a:xfrm>
-            <a:off x="3401568" y="1865376"/>
-            <a:ext cx="3017520" cy="475488"/>
+            <a:off x="5321807" y="2048256"/>
+            <a:ext cx="1188720" cy="640080"/>
           </a:xfrm>
           <a:prstGeom prst="rect">
             <a:avLst/>
@@ -3811,15 +3811,15 @@
           </a:bodyPr>
           <a:lstStyle/>
           <a:p>
-            <a:pPr algn="l"/>
-            <a:r>
-              <a:rPr sz="1150" b="0" i="0">
+            <a:pPr algn="ctr"/>
+            <a:r>
+              <a:rPr sz="1300" b="0" i="0">
                 <a:solidFill>
                   <a:srgbClr val="334155"/>
                 </a:solidFill>
                 <a:latin typeface="Segoe UI"/>
               </a:rPr>
-              <a:t>Real · n=8,578 (Amazon laptop)</a:t>
+              <a:t>+0.0822</a:t>
             </a:r>
           </a:p>
         </p:txBody>
@@ -3832,8 +3832,8 @@
         </p:nvSpPr>
         <p:spPr>
           <a:xfrm>
-            <a:off x="6601968" y="1865376"/>
-            <a:ext cx="960120" cy="475488"/>
+            <a:off x="6693407" y="2048256"/>
+            <a:ext cx="2926079" cy="640080"/>
           </a:xfrm>
           <a:prstGeom prst="rect">
             <a:avLst/>
@@ -3848,13 +3848,13 @@
           <a:p>
             <a:pPr algn="ctr"/>
             <a:r>
-              <a:rPr sz="1150" b="0" i="0">
+              <a:rPr sz="1300" b="0" i="0">
                 <a:solidFill>
                   <a:srgbClr val="334155"/>
                 </a:solidFill>
                 <a:latin typeface="Segoe UI"/>
               </a:rPr>
-              <a:t>0.3254</a:t>
+              <a:t>[+0.0629, +0.1021]</a:t>
             </a:r>
           </a:p>
         </p:txBody>
@@ -3867,8 +3867,8 @@
         </p:nvSpPr>
         <p:spPr>
           <a:xfrm>
-            <a:off x="7744968" y="1865376"/>
-            <a:ext cx="1234440" cy="475488"/>
+            <a:off x="9802367" y="2048256"/>
+            <a:ext cx="1737360" cy="640080"/>
           </a:xfrm>
           <a:prstGeom prst="rect">
             <a:avLst/>
@@ -3883,390 +3883,27 @@
           <a:p>
             <a:pPr algn="ctr"/>
             <a:r>
-              <a:rPr sz="1150" b="0" i="0">
-                <a:solidFill>
-                  <a:srgbClr val="334155"/>
-                </a:solidFill>
-                <a:latin typeface="Segoe UI"/>
-              </a:rPr>
-              <a:t>0.4141</a:t>
-            </a:r>
-          </a:p>
-        </p:txBody>
-      </p:sp>
-      <p:sp>
-        <p:nvSpPr>
-          <p:cNvPr id="18" name="TextBox 17"/>
-          <p:cNvSpPr txBox="1"/>
-          <p:nvPr/>
-        </p:nvSpPr>
-        <p:spPr>
-          <a:xfrm>
-            <a:off x="9162288" y="1865376"/>
-            <a:ext cx="1143000" cy="475488"/>
-          </a:xfrm>
-          <a:prstGeom prst="rect">
-            <a:avLst/>
-          </a:prstGeom>
-          <a:noFill/>
-        </p:spPr>
-        <p:txBody>
-          <a:bodyPr wrap="square" anchor="ctr" lIns="0" rIns="0" tIns="25400" bIns="25400">
-            <a:spAutoFit/>
-          </a:bodyPr>
-          <a:lstStyle/>
-          <a:p>
-            <a:pPr algn="ctr"/>
-            <a:r>
-              <a:rPr sz="1150" b="0" i="0">
-                <a:solidFill>
-                  <a:srgbClr val="334155"/>
-                </a:solidFill>
-                <a:latin typeface="Segoe UI"/>
-              </a:rPr>
-              <a:t>+8.9pp</a:t>
-            </a:r>
-          </a:p>
-        </p:txBody>
-      </p:sp>
-      <p:sp>
-        <p:nvSpPr>
-          <p:cNvPr id="19" name="TextBox 18"/>
-          <p:cNvSpPr txBox="1"/>
-          <p:nvPr/>
-        </p:nvSpPr>
-        <p:spPr>
-          <a:xfrm>
-            <a:off x="10488168" y="1865376"/>
-            <a:ext cx="1051560" cy="475488"/>
-          </a:xfrm>
-          <a:prstGeom prst="rect">
-            <a:avLst/>
-          </a:prstGeom>
-          <a:noFill/>
-        </p:spPr>
-        <p:txBody>
-          <a:bodyPr wrap="square" anchor="ctr" lIns="0" rIns="0" tIns="25400" bIns="25400">
-            <a:spAutoFit/>
-          </a:bodyPr>
-          <a:lstStyle/>
-          <a:p>
-            <a:pPr algn="ctr"/>
-            <a:r>
-              <a:rPr sz="1150" b="1" i="0">
+              <a:rPr sz="1300" b="1" i="0">
                 <a:solidFill>
                   <a:srgbClr val="047857"/>
                 </a:solidFill>
                 <a:latin typeface="Segoe UI"/>
               </a:rPr>
-              <a:t>Submitted</a:t>
-            </a:r>
-          </a:p>
-        </p:txBody>
-      </p:sp>
-      <p:sp>
-        <p:nvSpPr>
-          <p:cNvPr id="20" name="Rounded Rectangle 19"/>
+              <a:t>Supported</a:t>
+            </a:r>
+          </a:p>
+        </p:txBody>
+      </p:sp>
+      <p:sp>
+        <p:nvSpPr>
+          <p:cNvPr id="18" name="Rounded Rectangle 17"/>
           <p:cNvSpPr/>
           <p:nvPr/>
         </p:nvSpPr>
         <p:spPr>
           <a:xfrm>
-            <a:off x="475488" y="2340864"/>
-            <a:ext cx="11155680" cy="475488"/>
-          </a:xfrm>
-          <a:prstGeom prst="roundRect">
-            <a:avLst>
-              <a:gd name="adj" fmla="val 3000"/>
-            </a:avLst>
-          </a:prstGeom>
-          <a:solidFill>
-            <a:srgbClr val="D6F2E4"/>
-          </a:solidFill>
-          <a:ln w="12700">
-            <a:solidFill>
-              <a:srgbClr val="E2E8F0"/>
-            </a:solidFill>
-          </a:ln>
-          <a:effectLst/>
-        </p:spPr>
-        <p:style>
-          <a:lnRef idx="1">
-            <a:schemeClr val="accent1"/>
-          </a:lnRef>
-          <a:fillRef idx="3">
-            <a:schemeClr val="accent1"/>
-          </a:fillRef>
-          <a:effectRef idx="2">
-            <a:schemeClr val="accent1"/>
-          </a:effectRef>
-          <a:fontRef idx="minor">
-            <a:schemeClr val="lt1"/>
-          </a:fontRef>
-        </p:style>
-        <p:txBody>
-          <a:bodyPr rtlCol="0" anchor="ctr"/>
-          <a:lstStyle/>
-          <a:p>
-            <a:pPr algn="ctr"/>
-          </a:p>
-        </p:txBody>
-      </p:sp>
-      <p:sp>
-        <p:nvSpPr>
-          <p:cNvPr id="21" name="TextBox 20"/>
-          <p:cNvSpPr txBox="1"/>
-          <p:nvPr/>
-        </p:nvSpPr>
-        <p:spPr>
-          <a:xfrm>
-            <a:off x="566928" y="2340864"/>
-            <a:ext cx="1325880" cy="475488"/>
-          </a:xfrm>
-          <a:prstGeom prst="rect">
-            <a:avLst/>
-          </a:prstGeom>
-          <a:noFill/>
-        </p:spPr>
-        <p:txBody>
-          <a:bodyPr wrap="square" anchor="ctr" lIns="0" rIns="0" tIns="25400" bIns="25400">
-            <a:spAutoFit/>
-          </a:bodyPr>
-          <a:lstStyle/>
-          <a:p>
-            <a:pPr algn="ctr"/>
-            <a:r>
-              <a:rPr sz="1150" b="1" i="0">
-                <a:solidFill>
-                  <a:srgbClr val="0F172A"/>
-                </a:solidFill>
-                <a:latin typeface="Segoe UI"/>
-              </a:rPr>
-              <a:t>rus_restaurant</a:t>
-            </a:r>
-          </a:p>
-        </p:txBody>
-      </p:sp>
-      <p:sp>
-        <p:nvSpPr>
-          <p:cNvPr id="22" name="TextBox 21"/>
-          <p:cNvSpPr txBox="1"/>
-          <p:nvPr/>
-        </p:nvSpPr>
-        <p:spPr>
-          <a:xfrm>
-            <a:off x="2075688" y="2340864"/>
-            <a:ext cx="1143000" cy="475488"/>
-          </a:xfrm>
-          <a:prstGeom prst="rect">
-            <a:avLst/>
-          </a:prstGeom>
-          <a:noFill/>
-        </p:spPr>
-        <p:txBody>
-          <a:bodyPr wrap="square" anchor="ctr" lIns="0" rIns="0" tIns="25400" bIns="25400">
-            <a:spAutoFit/>
-          </a:bodyPr>
-          <a:lstStyle/>
-          <a:p>
-            <a:pPr algn="ctr"/>
-            <a:r>
-              <a:rPr sz="1150" b="0" i="0">
-                <a:solidFill>
-                  <a:srgbClr val="334155"/>
-                </a:solidFill>
-                <a:latin typeface="Segoe UI"/>
-              </a:rPr>
-              <a:t>DeepSeek</a:t>
-            </a:r>
-          </a:p>
-        </p:txBody>
-      </p:sp>
-      <p:sp>
-        <p:nvSpPr>
-          <p:cNvPr id="23" name="TextBox 22"/>
-          <p:cNvSpPr txBox="1"/>
-          <p:nvPr/>
-        </p:nvSpPr>
-        <p:spPr>
-          <a:xfrm>
-            <a:off x="3401568" y="2340864"/>
-            <a:ext cx="3017520" cy="475488"/>
-          </a:xfrm>
-          <a:prstGeom prst="rect">
-            <a:avLst/>
-          </a:prstGeom>
-          <a:noFill/>
-        </p:spPr>
-        <p:txBody>
-          <a:bodyPr wrap="square" anchor="ctr" lIns="0" rIns="0" tIns="25400" bIns="25400">
-            <a:spAutoFit/>
-          </a:bodyPr>
-          <a:lstStyle/>
-          <a:p>
-            <a:pPr algn="l"/>
-            <a:r>
-              <a:rPr sz="1150" b="0" i="0">
-                <a:solidFill>
-                  <a:srgbClr val="334155"/>
-                </a:solidFill>
-                <a:latin typeface="Segoe UI"/>
-              </a:rPr>
-              <a:t>Generated 4k · cap 3,000</a:t>
-            </a:r>
-          </a:p>
-        </p:txBody>
-      </p:sp>
-      <p:sp>
-        <p:nvSpPr>
-          <p:cNvPr id="24" name="TextBox 23"/>
-          <p:cNvSpPr txBox="1"/>
-          <p:nvPr/>
-        </p:nvSpPr>
-        <p:spPr>
-          <a:xfrm>
-            <a:off x="6601968" y="2340864"/>
-            <a:ext cx="960120" cy="475488"/>
-          </a:xfrm>
-          <a:prstGeom prst="rect">
-            <a:avLst/>
-          </a:prstGeom>
-          <a:noFill/>
-        </p:spPr>
-        <p:txBody>
-          <a:bodyPr wrap="square" anchor="ctr" lIns="0" rIns="0" tIns="25400" bIns="25400">
-            <a:spAutoFit/>
-          </a:bodyPr>
-          <a:lstStyle/>
-          <a:p>
-            <a:pPr algn="ctr"/>
-            <a:r>
-              <a:rPr sz="1150" b="0" i="0">
-                <a:solidFill>
-                  <a:srgbClr val="334155"/>
-                </a:solidFill>
-                <a:latin typeface="Segoe UI"/>
-              </a:rPr>
-              <a:t>0.5267</a:t>
-            </a:r>
-          </a:p>
-        </p:txBody>
-      </p:sp>
-      <p:sp>
-        <p:nvSpPr>
-          <p:cNvPr id="25" name="TextBox 24"/>
-          <p:cNvSpPr txBox="1"/>
-          <p:nvPr/>
-        </p:nvSpPr>
-        <p:spPr>
-          <a:xfrm>
-            <a:off x="7744968" y="2340864"/>
-            <a:ext cx="1234440" cy="475488"/>
-          </a:xfrm>
-          <a:prstGeom prst="rect">
-            <a:avLst/>
-          </a:prstGeom>
-          <a:noFill/>
-        </p:spPr>
-        <p:txBody>
-          <a:bodyPr wrap="square" anchor="ctr" lIns="0" rIns="0" tIns="25400" bIns="25400">
-            <a:spAutoFit/>
-          </a:bodyPr>
-          <a:lstStyle/>
-          <a:p>
-            <a:pPr algn="ctr"/>
-            <a:r>
-              <a:rPr sz="1150" b="0" i="0">
-                <a:solidFill>
-                  <a:srgbClr val="334155"/>
-                </a:solidFill>
-                <a:latin typeface="Segoe UI"/>
-              </a:rPr>
-              <a:t>0.6162</a:t>
-            </a:r>
-          </a:p>
-        </p:txBody>
-      </p:sp>
-      <p:sp>
-        <p:nvSpPr>
-          <p:cNvPr id="26" name="TextBox 25"/>
-          <p:cNvSpPr txBox="1"/>
-          <p:nvPr/>
-        </p:nvSpPr>
-        <p:spPr>
-          <a:xfrm>
-            <a:off x="9162288" y="2340864"/>
-            <a:ext cx="1143000" cy="475488"/>
-          </a:xfrm>
-          <a:prstGeom prst="rect">
-            <a:avLst/>
-          </a:prstGeom>
-          <a:noFill/>
-        </p:spPr>
-        <p:txBody>
-          <a:bodyPr wrap="square" anchor="ctr" lIns="0" rIns="0" tIns="25400" bIns="25400">
-            <a:spAutoFit/>
-          </a:bodyPr>
-          <a:lstStyle/>
-          <a:p>
-            <a:pPr algn="ctr"/>
-            <a:r>
-              <a:rPr sz="1150" b="0" i="0">
-                <a:solidFill>
-                  <a:srgbClr val="334155"/>
-                </a:solidFill>
-                <a:latin typeface="Segoe UI"/>
-              </a:rPr>
-              <a:t>+9.0pp</a:t>
-            </a:r>
-          </a:p>
-        </p:txBody>
-      </p:sp>
-      <p:sp>
-        <p:nvSpPr>
-          <p:cNvPr id="27" name="TextBox 26"/>
-          <p:cNvSpPr txBox="1"/>
-          <p:nvPr/>
-        </p:nvSpPr>
-        <p:spPr>
-          <a:xfrm>
-            <a:off x="10488168" y="2340864"/>
-            <a:ext cx="1051560" cy="475488"/>
-          </a:xfrm>
-          <a:prstGeom prst="rect">
-            <a:avLst/>
-          </a:prstGeom>
-          <a:noFill/>
-        </p:spPr>
-        <p:txBody>
-          <a:bodyPr wrap="square" anchor="ctr" lIns="0" rIns="0" tIns="25400" bIns="25400">
-            <a:spAutoFit/>
-          </a:bodyPr>
-          <a:lstStyle/>
-          <a:p>
-            <a:pPr algn="ctr"/>
-            <a:r>
-              <a:rPr sz="1150" b="1" i="0">
-                <a:solidFill>
-                  <a:srgbClr val="047857"/>
-                </a:solidFill>
-                <a:latin typeface="Segoe UI"/>
-              </a:rPr>
-              <a:t>Submitted</a:t>
-            </a:r>
-          </a:p>
-        </p:txBody>
-      </p:sp>
-      <p:sp>
-        <p:nvSpPr>
-          <p:cNvPr id="28" name="Rounded Rectangle 27"/>
-          <p:cNvSpPr/>
-          <p:nvPr/>
-        </p:nvSpPr>
-        <p:spPr>
-          <a:xfrm>
-            <a:off x="475488" y="2816352"/>
-            <a:ext cx="11155680" cy="475488"/>
+            <a:off x="475488" y="2688336"/>
+            <a:ext cx="11155680" cy="640080"/>
           </a:xfrm>
           <a:prstGeom prst="roundRect">
             <a:avLst>
@@ -4307,14 +3944,14 @@
       </p:sp>
       <p:sp>
         <p:nvSpPr>
-          <p:cNvPr id="29" name="TextBox 28"/>
-          <p:cNvSpPr txBox="1"/>
-          <p:nvPr/>
-        </p:nvSpPr>
-        <p:spPr>
-          <a:xfrm>
-            <a:off x="566928" y="2816352"/>
-            <a:ext cx="1325880" cy="475488"/>
+          <p:cNvPr id="19" name="TextBox 18"/>
+          <p:cNvSpPr txBox="1"/>
+          <p:nvPr/>
+        </p:nvSpPr>
+        <p:spPr>
+          <a:xfrm>
+            <a:off x="566928" y="2688336"/>
+            <a:ext cx="1737360" cy="640080"/>
           </a:xfrm>
           <a:prstGeom prst="rect">
             <a:avLst/>
@@ -4329,27 +3966,27 @@
           <a:p>
             <a:pPr algn="ctr"/>
             <a:r>
-              <a:rPr sz="1150" b="1" i="0">
+              <a:rPr sz="1300" b="1" i="0">
                 <a:solidFill>
                   <a:srgbClr val="0F172A"/>
                 </a:solidFill>
                 <a:latin typeface="Segoe UI"/>
               </a:rPr>
-              <a:t>ukr_restaurant</a:t>
-            </a:r>
-          </a:p>
-        </p:txBody>
-      </p:sp>
-      <p:sp>
-        <p:nvSpPr>
-          <p:cNvPr id="30" name="TextBox 29"/>
-          <p:cNvSpPr txBox="1"/>
-          <p:nvPr/>
-        </p:nvSpPr>
-        <p:spPr>
-          <a:xfrm>
-            <a:off x="2075688" y="2816352"/>
-            <a:ext cx="1143000" cy="475488"/>
+              <a:t>rus_restaurant</a:t>
+            </a:r>
+          </a:p>
+        </p:txBody>
+      </p:sp>
+      <p:sp>
+        <p:nvSpPr>
+          <p:cNvPr id="20" name="TextBox 19"/>
+          <p:cNvSpPr txBox="1"/>
+          <p:nvPr/>
+        </p:nvSpPr>
+        <p:spPr>
+          <a:xfrm>
+            <a:off x="2487168" y="2688336"/>
+            <a:ext cx="1234440" cy="640080"/>
           </a:xfrm>
           <a:prstGeom prst="rect">
             <a:avLst/>
@@ -4364,27 +4001,27 @@
           <a:p>
             <a:pPr algn="ctr"/>
             <a:r>
-              <a:rPr sz="1150" b="0" i="0">
+              <a:rPr sz="1300" b="0" i="0">
                 <a:solidFill>
                   <a:srgbClr val="334155"/>
                 </a:solidFill>
                 <a:latin typeface="Segoe UI"/>
               </a:rPr>
-              <a:t>DeepSeek</a:t>
-            </a:r>
-          </a:p>
-        </p:txBody>
-      </p:sp>
-      <p:sp>
-        <p:nvSpPr>
-          <p:cNvPr id="31" name="TextBox 30"/>
-          <p:cNvSpPr txBox="1"/>
-          <p:nvPr/>
-        </p:nvSpPr>
-        <p:spPr>
-          <a:xfrm>
-            <a:off x="3401568" y="2816352"/>
-            <a:ext cx="3017520" cy="475488"/>
+              <a:t>0.5189</a:t>
+            </a:r>
+          </a:p>
+        </p:txBody>
+      </p:sp>
+      <p:sp>
+        <p:nvSpPr>
+          <p:cNvPr id="21" name="TextBox 20"/>
+          <p:cNvSpPr txBox="1"/>
+          <p:nvPr/>
+        </p:nvSpPr>
+        <p:spPr>
+          <a:xfrm>
+            <a:off x="3904487" y="2688336"/>
+            <a:ext cx="1234440" cy="640080"/>
           </a:xfrm>
           <a:prstGeom prst="rect">
             <a:avLst/>
@@ -4399,27 +4036,27 @@
           <a:p>
             <a:pPr algn="l"/>
             <a:r>
-              <a:rPr sz="1150" b="0" i="0">
+              <a:rPr sz="1300" b="0" i="0">
                 <a:solidFill>
                   <a:srgbClr val="334155"/>
                 </a:solidFill>
                 <a:latin typeface="Segoe UI"/>
               </a:rPr>
-              <a:t>Translated · n=6,551 (RU→UK)</a:t>
-            </a:r>
-          </a:p>
-        </p:txBody>
-      </p:sp>
-      <p:sp>
-        <p:nvSpPr>
-          <p:cNvPr id="32" name="TextBox 31"/>
-          <p:cNvSpPr txBox="1"/>
-          <p:nvPr/>
-        </p:nvSpPr>
-        <p:spPr>
-          <a:xfrm>
-            <a:off x="6601968" y="2816352"/>
-            <a:ext cx="960120" cy="475488"/>
+              <a:t>0.4978</a:t>
+            </a:r>
+          </a:p>
+        </p:txBody>
+      </p:sp>
+      <p:sp>
+        <p:nvSpPr>
+          <p:cNvPr id="22" name="TextBox 21"/>
+          <p:cNvSpPr txBox="1"/>
+          <p:nvPr/>
+        </p:nvSpPr>
+        <p:spPr>
+          <a:xfrm>
+            <a:off x="5321807" y="2688336"/>
+            <a:ext cx="1188720" cy="640080"/>
           </a:xfrm>
           <a:prstGeom prst="rect">
             <a:avLst/>
@@ -4434,27 +4071,27 @@
           <a:p>
             <a:pPr algn="ctr"/>
             <a:r>
-              <a:rPr sz="1150" b="0" i="0">
+              <a:rPr sz="1300" b="0" i="0">
                 <a:solidFill>
                   <a:srgbClr val="334155"/>
                 </a:solidFill>
                 <a:latin typeface="Segoe UI"/>
               </a:rPr>
-              <a:t>0.5068</a:t>
-            </a:r>
-          </a:p>
-        </p:txBody>
-      </p:sp>
-      <p:sp>
-        <p:nvSpPr>
-          <p:cNvPr id="33" name="TextBox 32"/>
-          <p:cNvSpPr txBox="1"/>
-          <p:nvPr/>
-        </p:nvSpPr>
-        <p:spPr>
-          <a:xfrm>
-            <a:off x="7744968" y="2816352"/>
-            <a:ext cx="1234440" cy="475488"/>
+              <a:t>+0.0211</a:t>
+            </a:r>
+          </a:p>
+        </p:txBody>
+      </p:sp>
+      <p:sp>
+        <p:nvSpPr>
+          <p:cNvPr id="23" name="TextBox 22"/>
+          <p:cNvSpPr txBox="1"/>
+          <p:nvPr/>
+        </p:nvSpPr>
+        <p:spPr>
+          <a:xfrm>
+            <a:off x="6693407" y="2688336"/>
+            <a:ext cx="2926079" cy="640080"/>
           </a:xfrm>
           <a:prstGeom prst="rect">
             <a:avLst/>
@@ -4469,27 +4106,27 @@
           <a:p>
             <a:pPr algn="ctr"/>
             <a:r>
-              <a:rPr sz="1150" b="0" i="0">
+              <a:rPr sz="1300" b="0" i="0">
                 <a:solidFill>
                   <a:srgbClr val="334155"/>
                 </a:solidFill>
                 <a:latin typeface="Segoe UI"/>
               </a:rPr>
-              <a:t>0.5560</a:t>
-            </a:r>
-          </a:p>
-        </p:txBody>
-      </p:sp>
-      <p:sp>
-        <p:nvSpPr>
-          <p:cNvPr id="34" name="TextBox 33"/>
-          <p:cNvSpPr txBox="1"/>
-          <p:nvPr/>
-        </p:nvSpPr>
-        <p:spPr>
-          <a:xfrm>
-            <a:off x="9162288" y="2816352"/>
-            <a:ext cx="1143000" cy="475488"/>
+              <a:t>[+0.0005, +0.0431]</a:t>
+            </a:r>
+          </a:p>
+        </p:txBody>
+      </p:sp>
+      <p:sp>
+        <p:nvSpPr>
+          <p:cNvPr id="24" name="TextBox 23"/>
+          <p:cNvSpPr txBox="1"/>
+          <p:nvPr/>
+        </p:nvSpPr>
+        <p:spPr>
+          <a:xfrm>
+            <a:off x="9802367" y="2688336"/>
+            <a:ext cx="1737360" cy="640080"/>
           </a:xfrm>
           <a:prstGeom prst="rect">
             <a:avLst/>
@@ -4504,62 +4141,27 @@
           <a:p>
             <a:pPr algn="ctr"/>
             <a:r>
-              <a:rPr sz="1150" b="0" i="0">
-                <a:solidFill>
-                  <a:srgbClr val="334155"/>
-                </a:solidFill>
-                <a:latin typeface="Segoe UI"/>
-              </a:rPr>
-              <a:t>+4.9pp</a:t>
-            </a:r>
-          </a:p>
-        </p:txBody>
-      </p:sp>
-      <p:sp>
-        <p:nvSpPr>
-          <p:cNvPr id="35" name="TextBox 34"/>
-          <p:cNvSpPr txBox="1"/>
-          <p:nvPr/>
-        </p:nvSpPr>
-        <p:spPr>
-          <a:xfrm>
-            <a:off x="10488168" y="2816352"/>
-            <a:ext cx="1051560" cy="475488"/>
-          </a:xfrm>
-          <a:prstGeom prst="rect">
-            <a:avLst/>
-          </a:prstGeom>
-          <a:noFill/>
-        </p:spPr>
-        <p:txBody>
-          <a:bodyPr wrap="square" anchor="ctr" lIns="0" rIns="0" tIns="25400" bIns="25400">
-            <a:spAutoFit/>
-          </a:bodyPr>
-          <a:lstStyle/>
-          <a:p>
-            <a:pPr algn="ctr"/>
-            <a:r>
-              <a:rPr sz="1150" b="1" i="0">
+              <a:rPr sz="1300" b="1" i="0">
                 <a:solidFill>
                   <a:srgbClr val="047857"/>
                 </a:solidFill>
                 <a:latin typeface="Segoe UI"/>
               </a:rPr>
-              <a:t>Submitted</a:t>
-            </a:r>
-          </a:p>
-        </p:txBody>
-      </p:sp>
-      <p:sp>
-        <p:nvSpPr>
-          <p:cNvPr id="36" name="Rounded Rectangle 35"/>
+              <a:t>Supported</a:t>
+            </a:r>
+          </a:p>
+        </p:txBody>
+      </p:sp>
+      <p:sp>
+        <p:nvSpPr>
+          <p:cNvPr id="25" name="Rounded Rectangle 24"/>
           <p:cNvSpPr/>
           <p:nvPr/>
         </p:nvSpPr>
         <p:spPr>
           <a:xfrm>
-            <a:off x="475488" y="3291840"/>
-            <a:ext cx="11155680" cy="475488"/>
+            <a:off x="475488" y="3328416"/>
+            <a:ext cx="11155680" cy="640080"/>
           </a:xfrm>
           <a:prstGeom prst="roundRect">
             <a:avLst>
@@ -4600,14 +4202,14 @@
       </p:sp>
       <p:sp>
         <p:nvSpPr>
-          <p:cNvPr id="37" name="TextBox 36"/>
-          <p:cNvSpPr txBox="1"/>
-          <p:nvPr/>
-        </p:nvSpPr>
-        <p:spPr>
-          <a:xfrm>
-            <a:off x="566928" y="3291840"/>
-            <a:ext cx="1325880" cy="475488"/>
+          <p:cNvPr id="26" name="TextBox 25"/>
+          <p:cNvSpPr txBox="1"/>
+          <p:nvPr/>
+        </p:nvSpPr>
+        <p:spPr>
+          <a:xfrm>
+            <a:off x="566928" y="3328416"/>
+            <a:ext cx="1737360" cy="640080"/>
           </a:xfrm>
           <a:prstGeom prst="rect">
             <a:avLst/>
@@ -4622,27 +4224,27 @@
           <a:p>
             <a:pPr algn="ctr"/>
             <a:r>
-              <a:rPr sz="1150" b="1" i="0">
+              <a:rPr sz="1300" b="1" i="0">
                 <a:solidFill>
                   <a:srgbClr val="0F172A"/>
                 </a:solidFill>
                 <a:latin typeface="Segoe UI"/>
               </a:rPr>
-              <a:t>zho_restaurant</a:t>
-            </a:r>
-          </a:p>
-        </p:txBody>
-      </p:sp>
-      <p:sp>
-        <p:nvSpPr>
-          <p:cNvPr id="38" name="TextBox 37"/>
-          <p:cNvSpPr txBox="1"/>
-          <p:nvPr/>
-        </p:nvSpPr>
-        <p:spPr>
-          <a:xfrm>
-            <a:off x="2075688" y="3291840"/>
-            <a:ext cx="1143000" cy="475488"/>
+              <a:t>tat_restaurant</a:t>
+            </a:r>
+          </a:p>
+        </p:txBody>
+      </p:sp>
+      <p:sp>
+        <p:nvSpPr>
+          <p:cNvPr id="27" name="TextBox 26"/>
+          <p:cNvSpPr txBox="1"/>
+          <p:nvPr/>
+        </p:nvSpPr>
+        <p:spPr>
+          <a:xfrm>
+            <a:off x="2487168" y="3328416"/>
+            <a:ext cx="1234440" cy="640080"/>
           </a:xfrm>
           <a:prstGeom prst="rect">
             <a:avLst/>
@@ -4657,27 +4259,27 @@
           <a:p>
             <a:pPr algn="ctr"/>
             <a:r>
-              <a:rPr sz="1150" b="0" i="0">
+              <a:rPr sz="1300" b="0" i="0">
                 <a:solidFill>
                   <a:srgbClr val="334155"/>
                 </a:solidFill>
                 <a:latin typeface="Segoe UI"/>
               </a:rPr>
-              <a:t>DeepSeek</a:t>
-            </a:r>
-          </a:p>
-        </p:txBody>
-      </p:sp>
-      <p:sp>
-        <p:nvSpPr>
-          <p:cNvPr id="39" name="TextBox 38"/>
-          <p:cNvSpPr txBox="1"/>
-          <p:nvPr/>
-        </p:nvSpPr>
-        <p:spPr>
-          <a:xfrm>
-            <a:off x="3401568" y="3291840"/>
-            <a:ext cx="3017520" cy="475488"/>
+              <a:t>0.4311</a:t>
+            </a:r>
+          </a:p>
+        </p:txBody>
+      </p:sp>
+      <p:sp>
+        <p:nvSpPr>
+          <p:cNvPr id="28" name="TextBox 27"/>
+          <p:cNvSpPr txBox="1"/>
+          <p:nvPr/>
+        </p:nvSpPr>
+        <p:spPr>
+          <a:xfrm>
+            <a:off x="3904487" y="3328416"/>
+            <a:ext cx="1234440" cy="640080"/>
           </a:xfrm>
           <a:prstGeom prst="rect">
             <a:avLst/>
@@ -4692,27 +4294,27 @@
           <a:p>
             <a:pPr algn="l"/>
             <a:r>
-              <a:rPr sz="1150" b="0" i="0">
+              <a:rPr sz="1300" b="0" i="0">
                 <a:solidFill>
                   <a:srgbClr val="334155"/>
                 </a:solidFill>
                 <a:latin typeface="Segoe UI"/>
               </a:rPr>
-              <a:t>Real n=5,000 (dianping); Gen n=4,930 (superseded)</a:t>
-            </a:r>
-          </a:p>
-        </p:txBody>
-      </p:sp>
-      <p:sp>
-        <p:nvSpPr>
-          <p:cNvPr id="40" name="TextBox 39"/>
-          <p:cNvSpPr txBox="1"/>
-          <p:nvPr/>
-        </p:nvSpPr>
-        <p:spPr>
-          <a:xfrm>
-            <a:off x="6601968" y="3291840"/>
-            <a:ext cx="960120" cy="475488"/>
+              <a:t>0.4037</a:t>
+            </a:r>
+          </a:p>
+        </p:txBody>
+      </p:sp>
+      <p:sp>
+        <p:nvSpPr>
+          <p:cNvPr id="29" name="TextBox 28"/>
+          <p:cNvSpPr txBox="1"/>
+          <p:nvPr/>
+        </p:nvSpPr>
+        <p:spPr>
+          <a:xfrm>
+            <a:off x="5321807" y="3328416"/>
+            <a:ext cx="1188720" cy="640080"/>
           </a:xfrm>
           <a:prstGeom prst="rect">
             <a:avLst/>
@@ -4727,27 +4329,27 @@
           <a:p>
             <a:pPr algn="ctr"/>
             <a:r>
-              <a:rPr sz="1150" b="0" i="0">
+              <a:rPr sz="1300" b="0" i="0">
                 <a:solidFill>
                   <a:srgbClr val="334155"/>
                 </a:solidFill>
                 <a:latin typeface="Segoe UI"/>
               </a:rPr>
-              <a:t>0.4745</a:t>
-            </a:r>
-          </a:p>
-        </p:txBody>
-      </p:sp>
-      <p:sp>
-        <p:nvSpPr>
-          <p:cNvPr id="41" name="TextBox 40"/>
-          <p:cNvSpPr txBox="1"/>
-          <p:nvPr/>
-        </p:nvSpPr>
-        <p:spPr>
-          <a:xfrm>
-            <a:off x="7744968" y="3291840"/>
-            <a:ext cx="1234440" cy="475488"/>
+              <a:t>+0.0274</a:t>
+            </a:r>
+          </a:p>
+        </p:txBody>
+      </p:sp>
+      <p:sp>
+        <p:nvSpPr>
+          <p:cNvPr id="30" name="TextBox 29"/>
+          <p:cNvSpPr txBox="1"/>
+          <p:nvPr/>
+        </p:nvSpPr>
+        <p:spPr>
+          <a:xfrm>
+            <a:off x="6693407" y="3328416"/>
+            <a:ext cx="2926079" cy="640080"/>
           </a:xfrm>
           <a:prstGeom prst="rect">
             <a:avLst/>
@@ -4762,27 +4364,27 @@
           <a:p>
             <a:pPr algn="ctr"/>
             <a:r>
-              <a:rPr sz="1150" b="0" i="0">
+              <a:rPr sz="1300" b="0" i="0">
                 <a:solidFill>
                   <a:srgbClr val="334155"/>
                 </a:solidFill>
                 <a:latin typeface="Segoe UI"/>
               </a:rPr>
-              <a:t>0.5579</a:t>
-            </a:r>
-          </a:p>
-        </p:txBody>
-      </p:sp>
-      <p:sp>
-        <p:nvSpPr>
-          <p:cNvPr id="42" name="TextBox 41"/>
-          <p:cNvSpPr txBox="1"/>
-          <p:nvPr/>
-        </p:nvSpPr>
-        <p:spPr>
-          <a:xfrm>
-            <a:off x="9162288" y="3291840"/>
-            <a:ext cx="1143000" cy="475488"/>
+              <a:t>[+0.0071, +0.0482]</a:t>
+            </a:r>
+          </a:p>
+        </p:txBody>
+      </p:sp>
+      <p:sp>
+        <p:nvSpPr>
+          <p:cNvPr id="31" name="TextBox 30"/>
+          <p:cNvSpPr txBox="1"/>
+          <p:nvPr/>
+        </p:nvSpPr>
+        <p:spPr>
+          <a:xfrm>
+            <a:off x="9802367" y="3328416"/>
+            <a:ext cx="1737360" cy="640080"/>
           </a:xfrm>
           <a:prstGeom prst="rect">
             <a:avLst/>
@@ -4797,62 +4399,27 @@
           <a:p>
             <a:pPr algn="ctr"/>
             <a:r>
-              <a:rPr sz="1150" b="0" i="0">
-                <a:solidFill>
-                  <a:srgbClr val="334155"/>
-                </a:solidFill>
-                <a:latin typeface="Segoe UI"/>
-              </a:rPr>
-              <a:t>+8.3pp</a:t>
-            </a:r>
-          </a:p>
-        </p:txBody>
-      </p:sp>
-      <p:sp>
-        <p:nvSpPr>
-          <p:cNvPr id="43" name="TextBox 42"/>
-          <p:cNvSpPr txBox="1"/>
-          <p:nvPr/>
-        </p:nvSpPr>
-        <p:spPr>
-          <a:xfrm>
-            <a:off x="10488168" y="3291840"/>
-            <a:ext cx="1051560" cy="475488"/>
-          </a:xfrm>
-          <a:prstGeom prst="rect">
-            <a:avLst/>
-          </a:prstGeom>
-          <a:noFill/>
-        </p:spPr>
-        <p:txBody>
-          <a:bodyPr wrap="square" anchor="ctr" lIns="0" rIns="0" tIns="25400" bIns="25400">
-            <a:spAutoFit/>
-          </a:bodyPr>
-          <a:lstStyle/>
-          <a:p>
-            <a:pPr algn="ctr"/>
-            <a:r>
-              <a:rPr sz="1150" b="1" i="0">
+              <a:rPr sz="1300" b="1" i="0">
                 <a:solidFill>
                   <a:srgbClr val="047857"/>
                 </a:solidFill>
                 <a:latin typeface="Segoe UI"/>
               </a:rPr>
-              <a:t>Submitted</a:t>
-            </a:r>
-          </a:p>
-        </p:txBody>
-      </p:sp>
-      <p:sp>
-        <p:nvSpPr>
-          <p:cNvPr id="44" name="Rounded Rectangle 43"/>
+              <a:t>Supported</a:t>
+            </a:r>
+          </a:p>
+        </p:txBody>
+      </p:sp>
+      <p:sp>
+        <p:nvSpPr>
+          <p:cNvPr id="32" name="Rounded Rectangle 31"/>
           <p:cNvSpPr/>
           <p:nvPr/>
         </p:nvSpPr>
         <p:spPr>
           <a:xfrm>
-            <a:off x="475488" y="3767328"/>
-            <a:ext cx="11155680" cy="475488"/>
+            <a:off x="475488" y="3968496"/>
+            <a:ext cx="11155680" cy="640080"/>
           </a:xfrm>
           <a:prstGeom prst="roundRect">
             <a:avLst>
@@ -4893,14 +4460,14 @@
       </p:sp>
       <p:sp>
         <p:nvSpPr>
-          <p:cNvPr id="45" name="TextBox 44"/>
-          <p:cNvSpPr txBox="1"/>
-          <p:nvPr/>
-        </p:nvSpPr>
-        <p:spPr>
-          <a:xfrm>
-            <a:off x="566928" y="3767328"/>
-            <a:ext cx="1325880" cy="475488"/>
+          <p:cNvPr id="33" name="TextBox 32"/>
+          <p:cNvSpPr txBox="1"/>
+          <p:nvPr/>
+        </p:nvSpPr>
+        <p:spPr>
+          <a:xfrm>
+            <a:off x="566928" y="3968496"/>
+            <a:ext cx="1737360" cy="640080"/>
           </a:xfrm>
           <a:prstGeom prst="rect">
             <a:avLst/>
@@ -4915,27 +4482,27 @@
           <a:p>
             <a:pPr algn="ctr"/>
             <a:r>
-              <a:rPr sz="1150" b="1" i="0">
+              <a:rPr sz="1300" b="1" i="0">
                 <a:solidFill>
                   <a:srgbClr val="0F172A"/>
                 </a:solidFill>
                 <a:latin typeface="Segoe UI"/>
               </a:rPr>
-              <a:t>tat_restaurant</a:t>
-            </a:r>
-          </a:p>
-        </p:txBody>
-      </p:sp>
-      <p:sp>
-        <p:nvSpPr>
-          <p:cNvPr id="46" name="TextBox 45"/>
-          <p:cNvSpPr txBox="1"/>
-          <p:nvPr/>
-        </p:nvSpPr>
-        <p:spPr>
-          <a:xfrm>
-            <a:off x="2075688" y="3767328"/>
-            <a:ext cx="1143000" cy="475488"/>
+              <a:t>ukr_restaurant</a:t>
+            </a:r>
+          </a:p>
+        </p:txBody>
+      </p:sp>
+      <p:sp>
+        <p:nvSpPr>
+          <p:cNvPr id="34" name="TextBox 33"/>
+          <p:cNvSpPr txBox="1"/>
+          <p:nvPr/>
+        </p:nvSpPr>
+        <p:spPr>
+          <a:xfrm>
+            <a:off x="2487168" y="3968496"/>
+            <a:ext cx="1234440" cy="640080"/>
           </a:xfrm>
           <a:prstGeom prst="rect">
             <a:avLst/>
@@ -4950,27 +4517,27 @@
           <a:p>
             <a:pPr algn="ctr"/>
             <a:r>
-              <a:rPr sz="1150" b="0" i="0">
+              <a:rPr sz="1300" b="0" i="0">
                 <a:solidFill>
                   <a:srgbClr val="334155"/>
                 </a:solidFill>
                 <a:latin typeface="Segoe UI"/>
               </a:rPr>
-              <a:t>qwen (local)</a:t>
-            </a:r>
-          </a:p>
-        </p:txBody>
-      </p:sp>
-      <p:sp>
-        <p:nvSpPr>
-          <p:cNvPr id="47" name="TextBox 46"/>
-          <p:cNvSpPr txBox="1"/>
-          <p:nvPr/>
-        </p:nvSpPr>
-        <p:spPr>
-          <a:xfrm>
-            <a:off x="3401568" y="3767328"/>
-            <a:ext cx="3017520" cy="475488"/>
+              <a:t>0.4608</a:t>
+            </a:r>
+          </a:p>
+        </p:txBody>
+      </p:sp>
+      <p:sp>
+        <p:nvSpPr>
+          <p:cNvPr id="35" name="TextBox 34"/>
+          <p:cNvSpPr txBox="1"/>
+          <p:nvPr/>
+        </p:nvSpPr>
+        <p:spPr>
+          <a:xfrm>
+            <a:off x="3904487" y="3968496"/>
+            <a:ext cx="1234440" cy="640080"/>
           </a:xfrm>
           <a:prstGeom prst="rect">
             <a:avLst/>
@@ -4985,27 +4552,27 @@
           <a:p>
             <a:pPr algn="l"/>
             <a:r>
-              <a:rPr sz="1150" b="0" i="0">
+              <a:rPr sz="1300" b="0" i="0">
                 <a:solidFill>
                   <a:srgbClr val="334155"/>
                 </a:solidFill>
                 <a:latin typeface="Segoe UI"/>
               </a:rPr>
-              <a:t>Generated · n=3,986 (native Tatar)</a:t>
-            </a:r>
-          </a:p>
-        </p:txBody>
-      </p:sp>
-      <p:sp>
-        <p:nvSpPr>
-          <p:cNvPr id="48" name="TextBox 47"/>
-          <p:cNvSpPr txBox="1"/>
-          <p:nvPr/>
-        </p:nvSpPr>
-        <p:spPr>
-          <a:xfrm>
-            <a:off x="6601968" y="3767328"/>
-            <a:ext cx="960120" cy="475488"/>
+              <a:t>0.4215</a:t>
+            </a:r>
+          </a:p>
+        </p:txBody>
+      </p:sp>
+      <p:sp>
+        <p:nvSpPr>
+          <p:cNvPr id="36" name="TextBox 35"/>
+          <p:cNvSpPr txBox="1"/>
+          <p:nvPr/>
+        </p:nvSpPr>
+        <p:spPr>
+          <a:xfrm>
+            <a:off x="5321807" y="3968496"/>
+            <a:ext cx="1188720" cy="640080"/>
           </a:xfrm>
           <a:prstGeom prst="rect">
             <a:avLst/>
@@ -5020,27 +4587,27 @@
           <a:p>
             <a:pPr algn="ctr"/>
             <a:r>
-              <a:rPr sz="1150" b="0" i="0">
+              <a:rPr sz="1300" b="0" i="0">
                 <a:solidFill>
                   <a:srgbClr val="334155"/>
                 </a:solidFill>
                 <a:latin typeface="Segoe UI"/>
               </a:rPr>
-              <a:t>0.4821</a:t>
-            </a:r>
-          </a:p>
-        </p:txBody>
-      </p:sp>
-      <p:sp>
-        <p:nvSpPr>
-          <p:cNvPr id="49" name="TextBox 48"/>
-          <p:cNvSpPr txBox="1"/>
-          <p:nvPr/>
-        </p:nvSpPr>
-        <p:spPr>
-          <a:xfrm>
-            <a:off x="7744968" y="3767328"/>
-            <a:ext cx="1234440" cy="475488"/>
+              <a:t>+0.0393</a:t>
+            </a:r>
+          </a:p>
+        </p:txBody>
+      </p:sp>
+      <p:sp>
+        <p:nvSpPr>
+          <p:cNvPr id="37" name="TextBox 36"/>
+          <p:cNvSpPr txBox="1"/>
+          <p:nvPr/>
+        </p:nvSpPr>
+        <p:spPr>
+          <a:xfrm>
+            <a:off x="6693407" y="3968496"/>
+            <a:ext cx="2926079" cy="640080"/>
           </a:xfrm>
           <a:prstGeom prst="rect">
             <a:avLst/>
@@ -5055,27 +4622,27 @@
           <a:p>
             <a:pPr algn="ctr"/>
             <a:r>
-              <a:rPr sz="1150" b="0" i="0">
+              <a:rPr sz="1300" b="0" i="0">
                 <a:solidFill>
                   <a:srgbClr val="334155"/>
                 </a:solidFill>
                 <a:latin typeface="Segoe UI"/>
               </a:rPr>
-              <a:t>0.5327</a:t>
-            </a:r>
-          </a:p>
-        </p:txBody>
-      </p:sp>
-      <p:sp>
-        <p:nvSpPr>
-          <p:cNvPr id="50" name="TextBox 49"/>
-          <p:cNvSpPr txBox="1"/>
-          <p:nvPr/>
-        </p:nvSpPr>
-        <p:spPr>
-          <a:xfrm>
-            <a:off x="9162288" y="3767328"/>
-            <a:ext cx="1143000" cy="475488"/>
+              <a:t>[+0.0150, +0.0639]</a:t>
+            </a:r>
+          </a:p>
+        </p:txBody>
+      </p:sp>
+      <p:sp>
+        <p:nvSpPr>
+          <p:cNvPr id="38" name="TextBox 37"/>
+          <p:cNvSpPr txBox="1"/>
+          <p:nvPr/>
+        </p:nvSpPr>
+        <p:spPr>
+          <a:xfrm>
+            <a:off x="9802367" y="3968496"/>
+            <a:ext cx="1737360" cy="640080"/>
           </a:xfrm>
           <a:prstGeom prst="rect">
             <a:avLst/>
@@ -5090,62 +4657,27 @@
           <a:p>
             <a:pPr algn="ctr"/>
             <a:r>
-              <a:rPr sz="1150" b="0" i="0">
-                <a:solidFill>
-                  <a:srgbClr val="334155"/>
-                </a:solidFill>
-                <a:latin typeface="Segoe UI"/>
-              </a:rPr>
-              <a:t>+5.1pp</a:t>
-            </a:r>
-          </a:p>
-        </p:txBody>
-      </p:sp>
-      <p:sp>
-        <p:nvSpPr>
-          <p:cNvPr id="51" name="TextBox 50"/>
-          <p:cNvSpPr txBox="1"/>
-          <p:nvPr/>
-        </p:nvSpPr>
-        <p:spPr>
-          <a:xfrm>
-            <a:off x="10488168" y="3767328"/>
-            <a:ext cx="1051560" cy="475488"/>
-          </a:xfrm>
-          <a:prstGeom prst="rect">
-            <a:avLst/>
-          </a:prstGeom>
-          <a:noFill/>
-        </p:spPr>
-        <p:txBody>
-          <a:bodyPr wrap="square" anchor="ctr" lIns="0" rIns="0" tIns="25400" bIns="25400">
-            <a:spAutoFit/>
-          </a:bodyPr>
-          <a:lstStyle/>
-          <a:p>
-            <a:pPr algn="ctr"/>
-            <a:r>
-              <a:rPr sz="1150" b="1" i="0">
+              <a:rPr sz="1300" b="1" i="0">
                 <a:solidFill>
                   <a:srgbClr val="047857"/>
                 </a:solidFill>
                 <a:latin typeface="Segoe UI"/>
               </a:rPr>
-              <a:t>Submitted</a:t>
-            </a:r>
-          </a:p>
-        </p:txBody>
-      </p:sp>
-      <p:sp>
-        <p:nvSpPr>
-          <p:cNvPr id="52" name="Rounded Rectangle 51"/>
+              <a:t>Supported</a:t>
+            </a:r>
+          </a:p>
+        </p:txBody>
+      </p:sp>
+      <p:sp>
+        <p:nvSpPr>
+          <p:cNvPr id="39" name="Rounded Rectangle 38"/>
           <p:cNvSpPr/>
           <p:nvPr/>
         </p:nvSpPr>
         <p:spPr>
           <a:xfrm>
-            <a:off x="475488" y="4242816"/>
-            <a:ext cx="11155680" cy="475488"/>
+            <a:off x="475488" y="4608576"/>
+            <a:ext cx="11155680" cy="640080"/>
           </a:xfrm>
           <a:prstGeom prst="roundRect">
             <a:avLst>
@@ -5186,14 +4718,14 @@
       </p:sp>
       <p:sp>
         <p:nvSpPr>
-          <p:cNvPr id="53" name="TextBox 52"/>
-          <p:cNvSpPr txBox="1"/>
-          <p:nvPr/>
-        </p:nvSpPr>
-        <p:spPr>
-          <a:xfrm>
-            <a:off x="566928" y="4242816"/>
-            <a:ext cx="1325880" cy="475488"/>
+          <p:cNvPr id="40" name="TextBox 39"/>
+          <p:cNvSpPr txBox="1"/>
+          <p:nvPr/>
+        </p:nvSpPr>
+        <p:spPr>
+          <a:xfrm>
+            <a:off x="566928" y="4608576"/>
+            <a:ext cx="1737360" cy="640080"/>
           </a:xfrm>
           <a:prstGeom prst="rect">
             <a:avLst/>
@@ -5208,27 +4740,27 @@
           <a:p>
             <a:pPr algn="ctr"/>
             <a:r>
-              <a:rPr sz="1150" b="1" i="0">
+              <a:rPr sz="1300" b="1" i="0">
                 <a:solidFill>
                   <a:srgbClr val="0F172A"/>
                 </a:solidFill>
                 <a:latin typeface="Segoe UI"/>
               </a:rPr>
-              <a:t>zho_laptop</a:t>
-            </a:r>
-          </a:p>
-        </p:txBody>
-      </p:sp>
-      <p:sp>
-        <p:nvSpPr>
-          <p:cNvPr id="54" name="TextBox 53"/>
-          <p:cNvSpPr txBox="1"/>
-          <p:nvPr/>
-        </p:nvSpPr>
-        <p:spPr>
-          <a:xfrm>
-            <a:off x="2075688" y="4242816"/>
-            <a:ext cx="1143000" cy="475488"/>
+              <a:t>zho_restaurant</a:t>
+            </a:r>
+          </a:p>
+        </p:txBody>
+      </p:sp>
+      <p:sp>
+        <p:nvSpPr>
+          <p:cNvPr id="41" name="TextBox 40"/>
+          <p:cNvSpPr txBox="1"/>
+          <p:nvPr/>
+        </p:nvSpPr>
+        <p:spPr>
+          <a:xfrm>
+            <a:off x="2487168" y="4608576"/>
+            <a:ext cx="1234440" cy="640080"/>
           </a:xfrm>
           <a:prstGeom prst="rect">
             <a:avLst/>
@@ -5243,27 +4775,27 @@
           <a:p>
             <a:pPr algn="ctr"/>
             <a:r>
-              <a:rPr sz="1150" b="0" i="0">
+              <a:rPr sz="1300" b="0" i="0">
                 <a:solidFill>
                   <a:srgbClr val="334155"/>
                 </a:solidFill>
                 <a:latin typeface="Segoe UI"/>
               </a:rPr>
-              <a:t>qwen/DeepSeek</a:t>
-            </a:r>
-          </a:p>
-        </p:txBody>
-      </p:sp>
-      <p:sp>
-        <p:nvSpPr>
-          <p:cNvPr id="55" name="TextBox 54"/>
-          <p:cNvSpPr txBox="1"/>
-          <p:nvPr/>
-        </p:nvSpPr>
-        <p:spPr>
-          <a:xfrm>
-            <a:off x="3401568" y="4242816"/>
-            <a:ext cx="3017520" cy="475488"/>
+              <a:t>0.4660</a:t>
+            </a:r>
+          </a:p>
+        </p:txBody>
+      </p:sp>
+      <p:sp>
+        <p:nvSpPr>
+          <p:cNvPr id="42" name="TextBox 41"/>
+          <p:cNvSpPr txBox="1"/>
+          <p:nvPr/>
+        </p:nvSpPr>
+        <p:spPr>
+          <a:xfrm>
+            <a:off x="3904487" y="4608576"/>
+            <a:ext cx="1234440" cy="640080"/>
           </a:xfrm>
           <a:prstGeom prst="rect">
             <a:avLst/>
@@ -5278,27 +4810,27 @@
           <a:p>
             <a:pPr algn="l"/>
             <a:r>
-              <a:rPr sz="1150" b="0" i="0">
+              <a:rPr sz="1300" b="0" i="0">
                 <a:solidFill>
                   <a:srgbClr val="334155"/>
                 </a:solidFill>
                 <a:latin typeface="Segoe UI"/>
               </a:rPr>
-              <a:t>Gen n=4,923; Real n=1,673</a:t>
-            </a:r>
-          </a:p>
-        </p:txBody>
-      </p:sp>
-      <p:sp>
-        <p:nvSpPr>
-          <p:cNvPr id="56" name="TextBox 55"/>
-          <p:cNvSpPr txBox="1"/>
-          <p:nvPr/>
-        </p:nvSpPr>
-        <p:spPr>
-          <a:xfrm>
-            <a:off x="6601968" y="4242816"/>
-            <a:ext cx="960120" cy="475488"/>
+              <a:t>0.4798</a:t>
+            </a:r>
+          </a:p>
+        </p:txBody>
+      </p:sp>
+      <p:sp>
+        <p:nvSpPr>
+          <p:cNvPr id="43" name="TextBox 42"/>
+          <p:cNvSpPr txBox="1"/>
+          <p:nvPr/>
+        </p:nvSpPr>
+        <p:spPr>
+          <a:xfrm>
+            <a:off x="5321807" y="4608576"/>
+            <a:ext cx="1188720" cy="640080"/>
           </a:xfrm>
           <a:prstGeom prst="rect">
             <a:avLst/>
@@ -5313,27 +4845,27 @@
           <a:p>
             <a:pPr algn="ctr"/>
             <a:r>
-              <a:rPr sz="1150" b="0" i="0">
+              <a:rPr sz="1300" b="0" i="0">
                 <a:solidFill>
                   <a:srgbClr val="334155"/>
                 </a:solidFill>
                 <a:latin typeface="Segoe UI"/>
               </a:rPr>
-              <a:t>0.4487</a:t>
-            </a:r>
-          </a:p>
-        </p:txBody>
-      </p:sp>
-      <p:sp>
-        <p:nvSpPr>
-          <p:cNvPr id="57" name="TextBox 56"/>
-          <p:cNvSpPr txBox="1"/>
-          <p:nvPr/>
-        </p:nvSpPr>
-        <p:spPr>
-          <a:xfrm>
-            <a:off x="7744968" y="4242816"/>
-            <a:ext cx="1234440" cy="475488"/>
+              <a:t>−0.0137</a:t>
+            </a:r>
+          </a:p>
+        </p:txBody>
+      </p:sp>
+      <p:sp>
+        <p:nvSpPr>
+          <p:cNvPr id="44" name="TextBox 43"/>
+          <p:cNvSpPr txBox="1"/>
+          <p:nvPr/>
+        </p:nvSpPr>
+        <p:spPr>
+          <a:xfrm>
+            <a:off x="6693407" y="4608576"/>
+            <a:ext cx="2926079" cy="640080"/>
           </a:xfrm>
           <a:prstGeom prst="rect">
             <a:avLst/>
@@ -5348,27 +4880,27 @@
           <a:p>
             <a:pPr algn="ctr"/>
             <a:r>
-              <a:rPr sz="1150" b="0" i="0">
+              <a:rPr sz="1300" b="0" i="0">
                 <a:solidFill>
                   <a:srgbClr val="334155"/>
                 </a:solidFill>
                 <a:latin typeface="Segoe UI"/>
               </a:rPr>
-              <a:t>0.4454 / 0.4264</a:t>
-            </a:r>
-          </a:p>
-        </p:txBody>
-      </p:sp>
-      <p:sp>
-        <p:nvSpPr>
-          <p:cNvPr id="58" name="TextBox 57"/>
-          <p:cNvSpPr txBox="1"/>
-          <p:nvPr/>
-        </p:nvSpPr>
-        <p:spPr>
-          <a:xfrm>
-            <a:off x="9162288" y="4242816"/>
-            <a:ext cx="1143000" cy="475488"/>
+              <a:t>[−0.0289, +0.0014]</a:t>
+            </a:r>
+          </a:p>
+        </p:txBody>
+      </p:sp>
+      <p:sp>
+        <p:nvSpPr>
+          <p:cNvPr id="45" name="TextBox 44"/>
+          <p:cNvSpPr txBox="1"/>
+          <p:nvPr/>
+        </p:nvSpPr>
+        <p:spPr>
+          <a:xfrm>
+            <a:off x="9802367" y="4608576"/>
+            <a:ext cx="1737360" cy="640080"/>
           </a:xfrm>
           <a:prstGeom prst="rect">
             <a:avLst/>
@@ -5383,669 +4915,48 @@
           <a:p>
             <a:pPr algn="ctr"/>
             <a:r>
-              <a:rPr sz="1150" b="0" i="0">
-                <a:solidFill>
-                  <a:srgbClr val="334155"/>
-                </a:solidFill>
-                <a:latin typeface="Segoe UI"/>
-              </a:rPr>
-              <a:t>−0.3~−2.2pp</a:t>
-            </a:r>
-          </a:p>
-        </p:txBody>
-      </p:sp>
-      <p:sp>
-        <p:nvSpPr>
-          <p:cNvPr id="59" name="TextBox 58"/>
-          <p:cNvSpPr txBox="1"/>
-          <p:nvPr/>
-        </p:nvSpPr>
-        <p:spPr>
-          <a:xfrm>
-            <a:off x="10488168" y="4242816"/>
-            <a:ext cx="1051560" cy="475488"/>
-          </a:xfrm>
-          <a:prstGeom prst="rect">
-            <a:avLst/>
-          </a:prstGeom>
-          <a:noFill/>
-        </p:spPr>
-        <p:txBody>
-          <a:bodyPr wrap="square" anchor="ctr" lIns="0" rIns="0" tIns="25400" bIns="25400">
-            <a:spAutoFit/>
-          </a:bodyPr>
-          <a:lstStyle/>
-          <a:p>
-            <a:pPr algn="ctr"/>
-            <a:r>
-              <a:rPr sz="1150" b="1" i="0">
-                <a:solidFill>
-                  <a:srgbClr val="DC2626"/>
-                </a:solidFill>
-                <a:latin typeface="Segoe UI"/>
-              </a:rPr>
-              <a:t>Rejected</a:t>
-            </a:r>
-          </a:p>
-        </p:txBody>
-      </p:sp>
-      <p:sp>
-        <p:nvSpPr>
-          <p:cNvPr id="60" name="Rounded Rectangle 59"/>
-          <p:cNvSpPr/>
-          <p:nvPr/>
-        </p:nvSpPr>
-        <p:spPr>
-          <a:xfrm>
-            <a:off x="475488" y="4718304"/>
-            <a:ext cx="11155680" cy="475488"/>
-          </a:xfrm>
-          <a:prstGeom prst="roundRect">
-            <a:avLst>
-              <a:gd name="adj" fmla="val 3000"/>
-            </a:avLst>
-          </a:prstGeom>
-          <a:solidFill>
-            <a:srgbClr val="FFFFFF"/>
-          </a:solidFill>
-          <a:ln w="12700">
-            <a:solidFill>
-              <a:srgbClr val="E2E8F0"/>
-            </a:solidFill>
-          </a:ln>
-          <a:effectLst/>
-        </p:spPr>
-        <p:style>
-          <a:lnRef idx="1">
-            <a:schemeClr val="accent1"/>
-          </a:lnRef>
-          <a:fillRef idx="3">
-            <a:schemeClr val="accent1"/>
-          </a:fillRef>
-          <a:effectRef idx="2">
-            <a:schemeClr val="accent1"/>
-          </a:effectRef>
-          <a:fontRef idx="minor">
-            <a:schemeClr val="lt1"/>
-          </a:fontRef>
-        </p:style>
-        <p:txBody>
-          <a:bodyPr rtlCol="0" anchor="ctr"/>
-          <a:lstStyle/>
-          <a:p>
-            <a:pPr algn="ctr"/>
-          </a:p>
-        </p:txBody>
-      </p:sp>
-      <p:sp>
-        <p:nvSpPr>
-          <p:cNvPr id="61" name="TextBox 60"/>
-          <p:cNvSpPr txBox="1"/>
-          <p:nvPr/>
-        </p:nvSpPr>
-        <p:spPr>
-          <a:xfrm>
-            <a:off x="566928" y="4718304"/>
-            <a:ext cx="1325880" cy="475488"/>
-          </a:xfrm>
-          <a:prstGeom prst="rect">
-            <a:avLst/>
-          </a:prstGeom>
-          <a:noFill/>
-        </p:spPr>
-        <p:txBody>
-          <a:bodyPr wrap="square" anchor="ctr" lIns="0" rIns="0" tIns="25400" bIns="25400">
-            <a:spAutoFit/>
-          </a:bodyPr>
-          <a:lstStyle/>
-          <a:p>
-            <a:pPr algn="ctr"/>
-            <a:r>
-              <a:rPr sz="1150" b="1" i="0">
-                <a:solidFill>
-                  <a:srgbClr val="0F172A"/>
-                </a:solidFill>
-                <a:latin typeface="Segoe UI"/>
-              </a:rPr>
-              <a:t>jpn_hotel</a:t>
-            </a:r>
-          </a:p>
-        </p:txBody>
-      </p:sp>
-      <p:sp>
-        <p:nvSpPr>
-          <p:cNvPr id="62" name="TextBox 61"/>
-          <p:cNvSpPr txBox="1"/>
-          <p:nvPr/>
-        </p:nvSpPr>
-        <p:spPr>
-          <a:xfrm>
-            <a:off x="2075688" y="4718304"/>
-            <a:ext cx="1143000" cy="475488"/>
-          </a:xfrm>
-          <a:prstGeom prst="rect">
-            <a:avLst/>
-          </a:prstGeom>
-          <a:noFill/>
-        </p:spPr>
-        <p:txBody>
-          <a:bodyPr wrap="square" anchor="ctr" lIns="0" rIns="0" tIns="25400" bIns="25400">
-            <a:spAutoFit/>
-          </a:bodyPr>
-          <a:lstStyle/>
-          <a:p>
-            <a:pPr algn="ctr"/>
-            <a:r>
-              <a:rPr sz="1150" b="0" i="0">
-                <a:solidFill>
-                  <a:srgbClr val="334155"/>
-                </a:solidFill>
-                <a:latin typeface="Segoe UI"/>
-              </a:rPr>
-              <a:t>DeepSeek/qwen</a:t>
-            </a:r>
-          </a:p>
-        </p:txBody>
-      </p:sp>
-      <p:sp>
-        <p:nvSpPr>
-          <p:cNvPr id="63" name="TextBox 62"/>
-          <p:cNvSpPr txBox="1"/>
-          <p:nvPr/>
-        </p:nvSpPr>
-        <p:spPr>
-          <a:xfrm>
-            <a:off x="3401568" y="4718304"/>
-            <a:ext cx="3017520" cy="475488"/>
-          </a:xfrm>
-          <a:prstGeom prst="rect">
-            <a:avLst/>
-          </a:prstGeom>
-          <a:noFill/>
-        </p:spPr>
-        <p:txBody>
-          <a:bodyPr wrap="square" anchor="ctr" lIns="0" rIns="0" tIns="25400" bIns="25400">
+              <a:rPr sz="1300" b="1" i="0">
+                <a:solidFill>
+                  <a:srgbClr val="B45A09"/>
+                </a:solidFill>
+                <a:latin typeface="Segoe UI"/>
+              </a:rPr>
+              <a:t>Inconclusive</a:t>
+            </a:r>
+          </a:p>
+        </p:txBody>
+      </p:sp>
+      <p:sp>
+        <p:nvSpPr>
+          <p:cNvPr id="46" name="TextBox 45"/>
+          <p:cNvSpPr txBox="1"/>
+          <p:nvPr/>
+        </p:nvSpPr>
+        <p:spPr>
+          <a:xfrm>
+            <a:off x="502920" y="5477256"/>
+            <a:ext cx="11155680" cy="594360"/>
+          </a:xfrm>
+          <a:prstGeom prst="rect">
+            <a:avLst/>
+          </a:prstGeom>
+          <a:noFill/>
+        </p:spPr>
+        <p:txBody>
+          <a:bodyPr wrap="square" lIns="0" rIns="0" tIns="25400" bIns="25400">
             <a:spAutoFit/>
           </a:bodyPr>
           <a:lstStyle/>
           <a:p>
             <a:pPr algn="l"/>
             <a:r>
-              <a:rPr sz="1150" b="0" i="0">
-                <a:solidFill>
-                  <a:srgbClr val="334155"/>
-                </a:solidFill>
-                <a:latin typeface="Segoe UI"/>
-              </a:rPr>
-              <a:t>Generated · n=4,756 (no real corpus)</a:t>
-            </a:r>
-          </a:p>
-        </p:txBody>
-      </p:sp>
-      <p:sp>
-        <p:nvSpPr>
-          <p:cNvPr id="64" name="TextBox 63"/>
-          <p:cNvSpPr txBox="1"/>
-          <p:nvPr/>
-        </p:nvSpPr>
-        <p:spPr>
-          <a:xfrm>
-            <a:off x="6601968" y="4718304"/>
-            <a:ext cx="960120" cy="475488"/>
-          </a:xfrm>
-          <a:prstGeom prst="rect">
-            <a:avLst/>
-          </a:prstGeom>
-          <a:noFill/>
-        </p:spPr>
-        <p:txBody>
-          <a:bodyPr wrap="square" anchor="ctr" lIns="0" rIns="0" tIns="25400" bIns="25400">
-            <a:spAutoFit/>
-          </a:bodyPr>
-          <a:lstStyle/>
-          <a:p>
-            <a:pPr algn="ctr"/>
-            <a:r>
-              <a:rPr sz="1150" b="0" i="0">
-                <a:solidFill>
-                  <a:srgbClr val="334155"/>
-                </a:solidFill>
-                <a:latin typeface="Segoe UI"/>
-              </a:rPr>
-              <a:t>0.4466</a:t>
-            </a:r>
-          </a:p>
-        </p:txBody>
-      </p:sp>
-      <p:sp>
-        <p:nvSpPr>
-          <p:cNvPr id="65" name="TextBox 64"/>
-          <p:cNvSpPr txBox="1"/>
-          <p:nvPr/>
-        </p:nvSpPr>
-        <p:spPr>
-          <a:xfrm>
-            <a:off x="7744968" y="4718304"/>
-            <a:ext cx="1234440" cy="475488"/>
-          </a:xfrm>
-          <a:prstGeom prst="rect">
-            <a:avLst/>
-          </a:prstGeom>
-          <a:noFill/>
-        </p:spPr>
-        <p:txBody>
-          <a:bodyPr wrap="square" anchor="ctr" lIns="0" rIns="0" tIns="25400" bIns="25400">
-            <a:spAutoFit/>
-          </a:bodyPr>
-          <a:lstStyle/>
-          <a:p>
-            <a:pPr algn="ctr"/>
-            <a:r>
-              <a:rPr sz="1150" b="0" i="0">
-                <a:solidFill>
-                  <a:srgbClr val="334155"/>
-                </a:solidFill>
-                <a:latin typeface="Segoe UI"/>
-              </a:rPr>
-              <a:t>0.4281</a:t>
-            </a:r>
-          </a:p>
-        </p:txBody>
-      </p:sp>
-      <p:sp>
-        <p:nvSpPr>
-          <p:cNvPr id="66" name="TextBox 65"/>
-          <p:cNvSpPr txBox="1"/>
-          <p:nvPr/>
-        </p:nvSpPr>
-        <p:spPr>
-          <a:xfrm>
-            <a:off x="9162288" y="4718304"/>
-            <a:ext cx="1143000" cy="475488"/>
-          </a:xfrm>
-          <a:prstGeom prst="rect">
-            <a:avLst/>
-          </a:prstGeom>
-          <a:noFill/>
-        </p:spPr>
-        <p:txBody>
-          <a:bodyPr wrap="square" anchor="ctr" lIns="0" rIns="0" tIns="25400" bIns="25400">
-            <a:spAutoFit/>
-          </a:bodyPr>
-          <a:lstStyle/>
-          <a:p>
-            <a:pPr algn="ctr"/>
-            <a:r>
-              <a:rPr sz="1150" b="0" i="0">
-                <a:solidFill>
-                  <a:srgbClr val="334155"/>
-                </a:solidFill>
-                <a:latin typeface="Segoe UI"/>
-              </a:rPr>
-              <a:t>−1.9pp</a:t>
-            </a:r>
-          </a:p>
-        </p:txBody>
-      </p:sp>
-      <p:sp>
-        <p:nvSpPr>
-          <p:cNvPr id="67" name="TextBox 66"/>
-          <p:cNvSpPr txBox="1"/>
-          <p:nvPr/>
-        </p:nvSpPr>
-        <p:spPr>
-          <a:xfrm>
-            <a:off x="10488168" y="4718304"/>
-            <a:ext cx="1051560" cy="475488"/>
-          </a:xfrm>
-          <a:prstGeom prst="rect">
-            <a:avLst/>
-          </a:prstGeom>
-          <a:noFill/>
-        </p:spPr>
-        <p:txBody>
-          <a:bodyPr wrap="square" anchor="ctr" lIns="0" rIns="0" tIns="25400" bIns="25400">
-            <a:spAutoFit/>
-          </a:bodyPr>
-          <a:lstStyle/>
-          <a:p>
-            <a:pPr algn="ctr"/>
-            <a:r>
-              <a:rPr sz="1150" b="1" i="0">
-                <a:solidFill>
-                  <a:srgbClr val="DC2626"/>
-                </a:solidFill>
-                <a:latin typeface="Segoe UI"/>
-              </a:rPr>
-              <a:t>Rejected</a:t>
-            </a:r>
-          </a:p>
-        </p:txBody>
-      </p:sp>
-      <p:sp>
-        <p:nvSpPr>
-          <p:cNvPr id="68" name="Rounded Rectangle 67"/>
-          <p:cNvSpPr/>
-          <p:nvPr/>
-        </p:nvSpPr>
-        <p:spPr>
-          <a:xfrm>
-            <a:off x="475488" y="5193792"/>
-            <a:ext cx="11155680" cy="475488"/>
-          </a:xfrm>
-          <a:prstGeom prst="roundRect">
-            <a:avLst>
-              <a:gd name="adj" fmla="val 3000"/>
-            </a:avLst>
-          </a:prstGeom>
-          <a:solidFill>
-            <a:srgbClr val="FFFFFF"/>
-          </a:solidFill>
-          <a:ln w="12700">
-            <a:solidFill>
-              <a:srgbClr val="E2E8F0"/>
-            </a:solidFill>
-          </a:ln>
-          <a:effectLst/>
-        </p:spPr>
-        <p:style>
-          <a:lnRef idx="1">
-            <a:schemeClr val="accent1"/>
-          </a:lnRef>
-          <a:fillRef idx="3">
-            <a:schemeClr val="accent1"/>
-          </a:fillRef>
-          <a:effectRef idx="2">
-            <a:schemeClr val="accent1"/>
-          </a:effectRef>
-          <a:fontRef idx="minor">
-            <a:schemeClr val="lt1"/>
-          </a:fontRef>
-        </p:style>
-        <p:txBody>
-          <a:bodyPr rtlCol="0" anchor="ctr"/>
-          <a:lstStyle/>
-          <a:p>
-            <a:pPr algn="ctr"/>
-          </a:p>
-        </p:txBody>
-      </p:sp>
-      <p:sp>
-        <p:nvSpPr>
-          <p:cNvPr id="69" name="TextBox 68"/>
-          <p:cNvSpPr txBox="1"/>
-          <p:nvPr/>
-        </p:nvSpPr>
-        <p:spPr>
-          <a:xfrm>
-            <a:off x="566928" y="5193792"/>
-            <a:ext cx="1325880" cy="475488"/>
-          </a:xfrm>
-          <a:prstGeom prst="rect">
-            <a:avLst/>
-          </a:prstGeom>
-          <a:noFill/>
-        </p:spPr>
-        <p:txBody>
-          <a:bodyPr wrap="square" anchor="ctr" lIns="0" rIns="0" tIns="25400" bIns="25400">
-            <a:spAutoFit/>
-          </a:bodyPr>
-          <a:lstStyle/>
-          <a:p>
-            <a:pPr algn="ctr"/>
-            <a:r>
-              <a:rPr sz="1150" b="1" i="0">
-                <a:solidFill>
-                  <a:srgbClr val="0F172A"/>
-                </a:solidFill>
-                <a:latin typeface="Segoe UI"/>
-              </a:rPr>
-              <a:t>eng_restaurant</a:t>
-            </a:r>
-          </a:p>
-        </p:txBody>
-      </p:sp>
-      <p:sp>
-        <p:nvSpPr>
-          <p:cNvPr id="70" name="TextBox 69"/>
-          <p:cNvSpPr txBox="1"/>
-          <p:nvPr/>
-        </p:nvSpPr>
-        <p:spPr>
-          <a:xfrm>
-            <a:off x="2075688" y="5193792"/>
-            <a:ext cx="1143000" cy="475488"/>
-          </a:xfrm>
-          <a:prstGeom prst="rect">
-            <a:avLst/>
-          </a:prstGeom>
-          <a:noFill/>
-        </p:spPr>
-        <p:txBody>
-          <a:bodyPr wrap="square" anchor="ctr" lIns="0" rIns="0" tIns="25400" bIns="25400">
-            <a:spAutoFit/>
-          </a:bodyPr>
-          <a:lstStyle/>
-          <a:p>
-            <a:pPr algn="ctr"/>
-            <a:r>
-              <a:rPr sz="1150" b="0" i="0">
-                <a:solidFill>
-                  <a:srgbClr val="334155"/>
-                </a:solidFill>
-                <a:latin typeface="Segoe UI"/>
-              </a:rPr>
-              <a:t>DeepSeek/qwen</a:t>
-            </a:r>
-          </a:p>
-        </p:txBody>
-      </p:sp>
-      <p:sp>
-        <p:nvSpPr>
-          <p:cNvPr id="71" name="TextBox 70"/>
-          <p:cNvSpPr txBox="1"/>
-          <p:nvPr/>
-        </p:nvSpPr>
-        <p:spPr>
-          <a:xfrm>
-            <a:off x="3401568" y="5193792"/>
-            <a:ext cx="3017520" cy="475488"/>
-          </a:xfrm>
-          <a:prstGeom prst="rect">
-            <a:avLst/>
-          </a:prstGeom>
-          <a:noFill/>
-        </p:spPr>
-        <p:txBody>
-          <a:bodyPr wrap="square" anchor="ctr" lIns="0" rIns="0" tIns="25400" bIns="25400">
-            <a:spAutoFit/>
-          </a:bodyPr>
-          <a:lstStyle/>
-          <a:p>
-            <a:pPr algn="l"/>
-            <a:r>
-              <a:rPr sz="1150" b="0" i="0">
-                <a:solidFill>
-                  <a:srgbClr val="334155"/>
-                </a:solidFill>
-                <a:latin typeface="Segoe UI"/>
-              </a:rPr>
-              <a:t>Gen n=4,974; Real n=5,000 (Yelp)</a:t>
-            </a:r>
-          </a:p>
-        </p:txBody>
-      </p:sp>
-      <p:sp>
-        <p:nvSpPr>
-          <p:cNvPr id="72" name="TextBox 71"/>
-          <p:cNvSpPr txBox="1"/>
-          <p:nvPr/>
-        </p:nvSpPr>
-        <p:spPr>
-          <a:xfrm>
-            <a:off x="6601968" y="5193792"/>
-            <a:ext cx="960120" cy="475488"/>
-          </a:xfrm>
-          <a:prstGeom prst="rect">
-            <a:avLst/>
-          </a:prstGeom>
-          <a:noFill/>
-        </p:spPr>
-        <p:txBody>
-          <a:bodyPr wrap="square" anchor="ctr" lIns="0" rIns="0" tIns="25400" bIns="25400">
-            <a:spAutoFit/>
-          </a:bodyPr>
-          <a:lstStyle/>
-          <a:p>
-            <a:pPr algn="ctr"/>
-            <a:r>
-              <a:rPr sz="1150" b="0" i="0">
-                <a:solidFill>
-                  <a:srgbClr val="334155"/>
-                </a:solidFill>
-                <a:latin typeface="Segoe UI"/>
-              </a:rPr>
-              <a:t>0.6554</a:t>
-            </a:r>
-          </a:p>
-        </p:txBody>
-      </p:sp>
-      <p:sp>
-        <p:nvSpPr>
-          <p:cNvPr id="73" name="TextBox 72"/>
-          <p:cNvSpPr txBox="1"/>
-          <p:nvPr/>
-        </p:nvSpPr>
-        <p:spPr>
-          <a:xfrm>
-            <a:off x="7744968" y="5193792"/>
-            <a:ext cx="1234440" cy="475488"/>
-          </a:xfrm>
-          <a:prstGeom prst="rect">
-            <a:avLst/>
-          </a:prstGeom>
-          <a:noFill/>
-        </p:spPr>
-        <p:txBody>
-          <a:bodyPr wrap="square" anchor="ctr" lIns="0" rIns="0" tIns="25400" bIns="25400">
-            <a:spAutoFit/>
-          </a:bodyPr>
-          <a:lstStyle/>
-          <a:p>
-            <a:pPr algn="ctr"/>
-            <a:r>
-              <a:rPr sz="1150" b="0" i="0">
-                <a:solidFill>
-                  <a:srgbClr val="334155"/>
-                </a:solidFill>
-                <a:latin typeface="Segoe UI"/>
-              </a:rPr>
-              <a:t>0.6013 / 0.4190</a:t>
-            </a:r>
-          </a:p>
-        </p:txBody>
-      </p:sp>
-      <p:sp>
-        <p:nvSpPr>
-          <p:cNvPr id="74" name="TextBox 73"/>
-          <p:cNvSpPr txBox="1"/>
-          <p:nvPr/>
-        </p:nvSpPr>
-        <p:spPr>
-          <a:xfrm>
-            <a:off x="9162288" y="5193792"/>
-            <a:ext cx="1143000" cy="475488"/>
-          </a:xfrm>
-          <a:prstGeom prst="rect">
-            <a:avLst/>
-          </a:prstGeom>
-          <a:noFill/>
-        </p:spPr>
-        <p:txBody>
-          <a:bodyPr wrap="square" anchor="ctr" lIns="0" rIns="0" tIns="25400" bIns="25400">
-            <a:spAutoFit/>
-          </a:bodyPr>
-          <a:lstStyle/>
-          <a:p>
-            <a:pPr algn="ctr"/>
-            <a:r>
-              <a:rPr sz="1150" b="0" i="0">
-                <a:solidFill>
-                  <a:srgbClr val="334155"/>
-                </a:solidFill>
-                <a:latin typeface="Segoe UI"/>
-              </a:rPr>
-              <a:t>−5.4~−23.6pp</a:t>
-            </a:r>
-          </a:p>
-        </p:txBody>
-      </p:sp>
-      <p:sp>
-        <p:nvSpPr>
-          <p:cNvPr id="75" name="TextBox 74"/>
-          <p:cNvSpPr txBox="1"/>
-          <p:nvPr/>
-        </p:nvSpPr>
-        <p:spPr>
-          <a:xfrm>
-            <a:off x="10488168" y="5193792"/>
-            <a:ext cx="1051560" cy="475488"/>
-          </a:xfrm>
-          <a:prstGeom prst="rect">
-            <a:avLst/>
-          </a:prstGeom>
-          <a:noFill/>
-        </p:spPr>
-        <p:txBody>
-          <a:bodyPr wrap="square" anchor="ctr" lIns="0" rIns="0" tIns="25400" bIns="25400">
-            <a:spAutoFit/>
-          </a:bodyPr>
-          <a:lstStyle/>
-          <a:p>
-            <a:pPr algn="ctr"/>
-            <a:r>
-              <a:rPr sz="1150" b="1" i="0">
-                <a:solidFill>
-                  <a:srgbClr val="DC2626"/>
-                </a:solidFill>
-                <a:latin typeface="Segoe UI"/>
-              </a:rPr>
-              <a:t>Rejected</a:t>
-            </a:r>
-          </a:p>
-        </p:txBody>
-      </p:sp>
-      <p:sp>
-        <p:nvSpPr>
-          <p:cNvPr id="76" name="TextBox 75"/>
-          <p:cNvSpPr txBox="1"/>
-          <p:nvPr/>
-        </p:nvSpPr>
-        <p:spPr>
-          <a:xfrm>
-            <a:off x="502920" y="5833871"/>
-            <a:ext cx="11155680" cy="502920"/>
-          </a:xfrm>
-          <a:prstGeom prst="rect">
-            <a:avLst/>
-          </a:prstGeom>
-          <a:noFill/>
-        </p:spPr>
-        <p:txBody>
-          <a:bodyPr wrap="square" lIns="0" rIns="0" tIns="25400" bIns="25400">
-            <a:spAutoFit/>
-          </a:bodyPr>
-          <a:lstStyle/>
-          <a:p>
-            <a:pPr algn="l"/>
-            <a:r>
-              <a:rPr sz="1200" b="0" i="1">
+              <a:rPr sz="1300" b="0" i="1">
                 <a:solidFill>
                   <a:srgbClr val="64748B"/>
                 </a:solidFill>
                 <a:latin typeface="Segoe UI"/>
               </a:rPr>
-              <a:t>Five datasets adopt KD. Source labels describe the selected arm, not a universal ranking: zho_restaurant prefers real reviews, while rus_restaurant prefers a generated batch.</a:t>
+              <a:t>10,000 paired bootstrap resamples · seed 20260713. Systems, predictions and thresholds were frozen before gold retrieval. None of the eight main systems establishes test SOTA.</a:t>
             </a:r>
           </a:p>
         </p:txBody>
@@ -6106,7 +5017,7 @@
                 </a:solidFill>
                 <a:latin typeface="Segoe UI"/>
               </a:rPr>
-              <a:t>ABLATION DESIGN</a:t>
+              <a:t>ABLATION DESIGN · DEV EVIDENCE</a:t>
             </a:r>
           </a:p>
         </p:txBody>
@@ -7516,7 +6427,7 @@
                 </a:solidFill>
                 <a:latin typeface="Segoe UI"/>
               </a:rPr>
-              <a:t>QUANTITY CONTROL</a:t>
+              <a:t>QUANTITY CONTROL · DEV EVIDENCE</a:t>
             </a:r>
           </a:p>
         </p:txBody>
@@ -8410,7 +7321,7 @@
                 </a:solidFill>
                 <a:latin typeface="Segoe UI"/>
               </a:rPr>
-              <a:t>Five Conclusions Supported by the Full Ablation Matrix</a:t>
+              <a:t>Six Conclusions Within the Evidence Boundary</a:t>
             </a:r>
           </a:p>
         </p:txBody>
@@ -8423,8 +7334,8 @@
         </p:nvSpPr>
         <p:spPr>
           <a:xfrm>
-            <a:off x="566928" y="1389888"/>
-            <a:ext cx="11018520" cy="777240"/>
+            <a:off x="566928" y="1353312"/>
+            <a:ext cx="11018520" cy="667512"/>
           </a:xfrm>
           <a:prstGeom prst="roundRect">
             <a:avLst>
@@ -8469,8 +7380,8 @@
         </p:nvSpPr>
         <p:spPr>
           <a:xfrm>
-            <a:off x="749808" y="1508760"/>
-            <a:ext cx="548640" cy="530352"/>
+            <a:off x="749808" y="1444752"/>
+            <a:ext cx="493776" cy="475488"/>
           </a:xfrm>
           <a:prstGeom prst="roundRect">
             <a:avLst>
@@ -8515,8 +7426,8 @@
         </p:nvSpPr>
         <p:spPr>
           <a:xfrm>
-            <a:off x="749808" y="1508760"/>
-            <a:ext cx="548640" cy="530352"/>
+            <a:off x="749808" y="1444752"/>
+            <a:ext cx="493776" cy="475488"/>
           </a:xfrm>
           <a:prstGeom prst="rect">
             <a:avLst/>
@@ -8531,7 +7442,7 @@
           <a:p>
             <a:pPr algn="ctr"/>
             <a:r>
-              <a:rPr sz="1900" b="1" i="0">
+              <a:rPr sz="1700" b="1" i="0">
                 <a:solidFill>
                   <a:srgbClr val="FFFFFF"/>
                 </a:solidFill>
@@ -8550,8 +7461,8 @@
         </p:nvSpPr>
         <p:spPr>
           <a:xfrm>
-            <a:off x="1517904" y="1472184"/>
-            <a:ext cx="3886200" cy="566928"/>
+            <a:off x="1444752" y="1408176"/>
+            <a:ext cx="3977639" cy="512064"/>
           </a:xfrm>
           <a:prstGeom prst="rect">
             <a:avLst/>
@@ -8566,13 +7477,13 @@
           <a:p>
             <a:pPr algn="l"/>
             <a:r>
-              <a:rPr sz="1650" b="1" i="0">
+              <a:rPr sz="1520" b="1" i="0">
                 <a:solidFill>
                   <a:srgbClr val="1D4ED8"/>
                 </a:solidFill>
                 <a:latin typeface="Segoe UI"/>
               </a:rPr>
-              <a:t>Complementarity decides whether KD helps</a:t>
+              <a:t>KD gains are conditional</a:t>
             </a:r>
           </a:p>
         </p:txBody>
@@ -8585,8 +7496,8 @@
         </p:nvSpPr>
         <p:spPr>
           <a:xfrm>
-            <a:off x="5596128" y="1481328"/>
-            <a:ext cx="5486400" cy="502920"/>
+            <a:off x="5504688" y="1408176"/>
+            <a:ext cx="5669280" cy="512064"/>
           </a:xfrm>
           <a:prstGeom prst="rect">
             <a:avLst/>
@@ -8601,13 +7512,13 @@
           <a:p>
             <a:pPr algn="l"/>
             <a:r>
-              <a:rPr sz="1420" b="0" i="0">
+              <a:rPr sz="1280" b="0" i="0">
                 <a:solidFill>
                   <a:srgbClr val="334155"/>
                 </a:solidFill>
                 <a:latin typeface="Segoe UI"/>
               </a:rPr>
-              <a:t>Silver must add coverage or priors missing from gold/base.</a:t>
+              <a:t>Complementary, accurate coverage is a supported interpretation—not a universal law.</a:t>
             </a:r>
           </a:p>
         </p:txBody>
@@ -8620,8 +7531,8 @@
         </p:nvSpPr>
         <p:spPr>
           <a:xfrm>
-            <a:off x="566928" y="2350008"/>
-            <a:ext cx="11018520" cy="777240"/>
+            <a:off x="566928" y="2185416"/>
+            <a:ext cx="11018520" cy="667512"/>
           </a:xfrm>
           <a:prstGeom prst="roundRect">
             <a:avLst>
@@ -8666,8 +7577,8 @@
         </p:nvSpPr>
         <p:spPr>
           <a:xfrm>
-            <a:off x="749808" y="2468880"/>
-            <a:ext cx="548640" cy="530352"/>
+            <a:off x="749808" y="2276856"/>
+            <a:ext cx="493776" cy="475488"/>
           </a:xfrm>
           <a:prstGeom prst="roundRect">
             <a:avLst>
@@ -8712,8 +7623,8 @@
         </p:nvSpPr>
         <p:spPr>
           <a:xfrm>
-            <a:off x="749808" y="2468880"/>
-            <a:ext cx="548640" cy="530352"/>
+            <a:off x="749808" y="2276856"/>
+            <a:ext cx="493776" cy="475488"/>
           </a:xfrm>
           <a:prstGeom prst="rect">
             <a:avLst/>
@@ -8728,7 +7639,7 @@
           <a:p>
             <a:pPr algn="ctr"/>
             <a:r>
-              <a:rPr sz="1900" b="1" i="0">
+              <a:rPr sz="1700" b="1" i="0">
                 <a:solidFill>
                   <a:srgbClr val="FFFFFF"/>
                 </a:solidFill>
@@ -8747,8 +7658,8 @@
         </p:nvSpPr>
         <p:spPr>
           <a:xfrm>
-            <a:off x="1517904" y="2432304"/>
-            <a:ext cx="3886200" cy="566928"/>
+            <a:off x="1444752" y="2240280"/>
+            <a:ext cx="3977639" cy="512064"/>
           </a:xfrm>
           <a:prstGeom prst="rect">
             <a:avLst/>
@@ -8763,13 +7674,13 @@
           <a:p>
             <a:pPr algn="l"/>
             <a:r>
-              <a:rPr sz="1650" b="1" i="0">
+              <a:rPr sz="1520" b="1" i="0">
                 <a:solidFill>
                   <a:srgbClr val="B45A09"/>
                 </a:solidFill>
                 <a:latin typeface="Segoe UI"/>
               </a:rPr>
-              <a:t>Teacher quality is domain-dependent</a:t>
+              <a:t>DeepSeek is more robust overall</a:t>
             </a:r>
           </a:p>
         </p:txBody>
@@ -8782,8 +7693,8 @@
         </p:nvSpPr>
         <p:spPr>
           <a:xfrm>
-            <a:off x="5596128" y="2441448"/>
-            <a:ext cx="5486400" cy="502920"/>
+            <a:off x="5504688" y="2240280"/>
+            <a:ext cx="5669280" cy="512064"/>
           </a:xfrm>
           <a:prstGeom prst="rect">
             <a:avLst/>
@@ -8798,13 +7709,13 @@
           <a:p>
             <a:pPr algn="l"/>
             <a:r>
-              <a:rPr sz="1420" b="0" i="0">
+              <a:rPr sz="1280" b="0" i="0">
                 <a:solidFill>
                   <a:srgbClr val="334155"/>
                 </a:solidFill>
                 <a:latin typeface="Segoe UI"/>
               </a:rPr>
-              <a:t>Qwen is competitive in many domains but collapses on eng_restaurant.</a:t>
+              <a:t>Direct fidelity is 8/8 higher by point estimate; only 3/8 gaps are supported.</a:t>
             </a:r>
           </a:p>
         </p:txBody>
@@ -8817,8 +7728,8 @@
         </p:nvSpPr>
         <p:spPr>
           <a:xfrm>
-            <a:off x="566928" y="3310128"/>
-            <a:ext cx="11018520" cy="777240"/>
+            <a:off x="566928" y="3017520"/>
+            <a:ext cx="11018520" cy="667512"/>
           </a:xfrm>
           <a:prstGeom prst="roundRect">
             <a:avLst>
@@ -8863,8 +7774,8 @@
         </p:nvSpPr>
         <p:spPr>
           <a:xfrm>
-            <a:off x="749808" y="3429000"/>
-            <a:ext cx="548640" cy="530352"/>
+            <a:off x="749808" y="3108960"/>
+            <a:ext cx="493776" cy="475488"/>
           </a:xfrm>
           <a:prstGeom prst="roundRect">
             <a:avLst>
@@ -8909,8 +7820,8 @@
         </p:nvSpPr>
         <p:spPr>
           <a:xfrm>
-            <a:off x="749808" y="3429000"/>
-            <a:ext cx="548640" cy="530352"/>
+            <a:off x="749808" y="3108960"/>
+            <a:ext cx="493776" cy="475488"/>
           </a:xfrm>
           <a:prstGeom prst="rect">
             <a:avLst/>
@@ -8925,7 +7836,7 @@
           <a:p>
             <a:pPr algn="ctr"/>
             <a:r>
-              <a:rPr sz="1900" b="1" i="0">
+              <a:rPr sz="1700" b="1" i="0">
                 <a:solidFill>
                   <a:srgbClr val="FFFFFF"/>
                 </a:solidFill>
@@ -8944,8 +7855,8 @@
         </p:nvSpPr>
         <p:spPr>
           <a:xfrm>
-            <a:off x="1517904" y="3392424"/>
-            <a:ext cx="3886200" cy="566928"/>
+            <a:off x="1444752" y="3072384"/>
+            <a:ext cx="3977639" cy="512064"/>
           </a:xfrm>
           <a:prstGeom prst="rect">
             <a:avLst/>
@@ -8960,7 +7871,7 @@
           <a:p>
             <a:pPr algn="l"/>
             <a:r>
-              <a:rPr sz="1650" b="1" i="0">
+              <a:rPr sz="1520" b="1" i="0">
                 <a:solidFill>
                   <a:srgbClr val="047857"/>
                 </a:solidFill>
@@ -8979,8 +7890,8 @@
         </p:nvSpPr>
         <p:spPr>
           <a:xfrm>
-            <a:off x="5596128" y="3401568"/>
-            <a:ext cx="5486400" cy="502920"/>
+            <a:off x="5504688" y="3072384"/>
+            <a:ext cx="5669280" cy="512064"/>
           </a:xfrm>
           <a:prstGeom prst="rect">
             <a:avLst/>
@@ -8995,7 +7906,7 @@
           <a:p>
             <a:pPr algn="l"/>
             <a:r>
-              <a:rPr sz="1420" b="0" i="0">
+              <a:rPr sz="1280" b="0" i="0">
                 <a:solidFill>
                   <a:srgbClr val="334155"/>
                 </a:solidFill>
@@ -9014,8 +7925,8 @@
         </p:nvSpPr>
         <p:spPr>
           <a:xfrm>
-            <a:off x="566928" y="4270248"/>
-            <a:ext cx="11018520" cy="777240"/>
+            <a:off x="566928" y="3849624"/>
+            <a:ext cx="11018520" cy="667512"/>
           </a:xfrm>
           <a:prstGeom prst="roundRect">
             <a:avLst>
@@ -9060,8 +7971,8 @@
         </p:nvSpPr>
         <p:spPr>
           <a:xfrm>
-            <a:off x="749808" y="4389120"/>
-            <a:ext cx="548640" cy="530352"/>
+            <a:off x="749808" y="3941063"/>
+            <a:ext cx="493776" cy="475488"/>
           </a:xfrm>
           <a:prstGeom prst="roundRect">
             <a:avLst>
@@ -9106,8 +8017,8 @@
         </p:nvSpPr>
         <p:spPr>
           <a:xfrm>
-            <a:off x="749808" y="4389120"/>
-            <a:ext cx="548640" cy="530352"/>
+            <a:off x="749808" y="3941063"/>
+            <a:ext cx="493776" cy="475488"/>
           </a:xfrm>
           <a:prstGeom prst="rect">
             <a:avLst/>
@@ -9122,7 +8033,7 @@
           <a:p>
             <a:pPr algn="ctr"/>
             <a:r>
-              <a:rPr sz="1900" b="1" i="0">
+              <a:rPr sz="1700" b="1" i="0">
                 <a:solidFill>
                   <a:srgbClr val="FFFFFF"/>
                 </a:solidFill>
@@ -9141,8 +8052,8 @@
         </p:nvSpPr>
         <p:spPr>
           <a:xfrm>
-            <a:off x="1517904" y="4352544"/>
-            <a:ext cx="3886200" cy="566928"/>
+            <a:off x="1444752" y="3904487"/>
+            <a:ext cx="3977639" cy="512064"/>
           </a:xfrm>
           <a:prstGeom prst="rect">
             <a:avLst/>
@@ -9157,7 +8068,7 @@
           <a:p>
             <a:pPr algn="l"/>
             <a:r>
-              <a:rPr sz="1650" b="1" i="0">
+              <a:rPr sz="1520" b="1" i="0">
                 <a:solidFill>
                   <a:srgbClr val="DC2626"/>
                 </a:solidFill>
@@ -9176,8 +8087,8 @@
         </p:nvSpPr>
         <p:spPr>
           <a:xfrm>
-            <a:off x="5596128" y="4361688"/>
-            <a:ext cx="5486400" cy="502920"/>
+            <a:off x="5504688" y="3904487"/>
+            <a:ext cx="5669280" cy="512064"/>
           </a:xfrm>
           <a:prstGeom prst="rect">
             <a:avLst/>
@@ -9192,7 +8103,7 @@
           <a:p>
             <a:pPr algn="l"/>
             <a:r>
-              <a:rPr sz="1420" b="0" i="0">
+              <a:rPr sz="1280" b="0" i="0">
                 <a:solidFill>
                   <a:srgbClr val="334155"/>
                 </a:solidFill>
@@ -9211,8 +8122,8 @@
         </p:nvSpPr>
         <p:spPr>
           <a:xfrm>
-            <a:off x="566928" y="5230368"/>
-            <a:ext cx="11018520" cy="777240"/>
+            <a:off x="566928" y="4681728"/>
+            <a:ext cx="11018520" cy="667512"/>
           </a:xfrm>
           <a:prstGeom prst="roundRect">
             <a:avLst>
@@ -9257,8 +8168,8 @@
         </p:nvSpPr>
         <p:spPr>
           <a:xfrm>
-            <a:off x="749808" y="5349240"/>
-            <a:ext cx="548640" cy="530352"/>
+            <a:off x="749808" y="4773168"/>
+            <a:ext cx="493776" cy="475488"/>
           </a:xfrm>
           <a:prstGeom prst="roundRect">
             <a:avLst>
@@ -9303,8 +8214,8 @@
         </p:nvSpPr>
         <p:spPr>
           <a:xfrm>
-            <a:off x="749808" y="5349240"/>
-            <a:ext cx="548640" cy="530352"/>
+            <a:off x="749808" y="4773168"/>
+            <a:ext cx="493776" cy="475488"/>
           </a:xfrm>
           <a:prstGeom prst="rect">
             <a:avLst/>
@@ -9319,7 +8230,7 @@
           <a:p>
             <a:pPr algn="ctr"/>
             <a:r>
-              <a:rPr sz="1900" b="1" i="0">
+              <a:rPr sz="1700" b="1" i="0">
                 <a:solidFill>
                   <a:srgbClr val="FFFFFF"/>
                 </a:solidFill>
@@ -9338,8 +8249,8 @@
         </p:nvSpPr>
         <p:spPr>
           <a:xfrm>
-            <a:off x="1517904" y="5312664"/>
-            <a:ext cx="3886200" cy="566928"/>
+            <a:off x="1444752" y="4736592"/>
+            <a:ext cx="3977639" cy="512064"/>
           </a:xfrm>
           <a:prstGeom prst="rect">
             <a:avLst/>
@@ -9354,7 +8265,7 @@
           <a:p>
             <a:pPr algn="l"/>
             <a:r>
-              <a:rPr sz="1650" b="1" i="0">
+              <a:rPr sz="1520" b="1" i="0">
                 <a:solidFill>
                   <a:srgbClr val="1E293B"/>
                 </a:solidFill>
@@ -9373,8 +8284,8 @@
         </p:nvSpPr>
         <p:spPr>
           <a:xfrm>
-            <a:off x="5596128" y="5321808"/>
-            <a:ext cx="5486400" cy="502920"/>
+            <a:off x="5504688" y="4736592"/>
+            <a:ext cx="5669280" cy="512064"/>
           </a:xfrm>
           <a:prstGeom prst="rect">
             <a:avLst/>
@@ -9389,13 +8300,210 @@
           <a:p>
             <a:pPr algn="l"/>
             <a:r>
-              <a:rPr sz="1420" b="0" i="0">
+              <a:rPr sz="1280" b="0" i="0">
                 <a:solidFill>
                   <a:srgbClr val="334155"/>
                 </a:solidFill>
                 <a:latin typeface="Segoe UI"/>
               </a:rPr>
               <a:t>More is not automatically better; no universal cap is supported.</a:t>
+            </a:r>
+          </a:p>
+        </p:txBody>
+      </p:sp>
+      <p:sp>
+        <p:nvSpPr>
+          <p:cNvPr id="29" name="Rounded Rectangle 28"/>
+          <p:cNvSpPr/>
+          <p:nvPr/>
+        </p:nvSpPr>
+        <p:spPr>
+          <a:xfrm>
+            <a:off x="566928" y="5513831"/>
+            <a:ext cx="11018520" cy="667512"/>
+          </a:xfrm>
+          <a:prstGeom prst="roundRect">
+            <a:avLst>
+              <a:gd name="adj" fmla="val 5000"/>
+            </a:avLst>
+          </a:prstGeom>
+          <a:solidFill>
+            <a:srgbClr val="DEEAFB"/>
+          </a:solidFill>
+          <a:ln>
+            <a:noFill/>
+          </a:ln>
+          <a:effectLst/>
+        </p:spPr>
+        <p:style>
+          <a:lnRef idx="1">
+            <a:schemeClr val="accent1"/>
+          </a:lnRef>
+          <a:fillRef idx="3">
+            <a:schemeClr val="accent1"/>
+          </a:fillRef>
+          <a:effectRef idx="2">
+            <a:schemeClr val="accent1"/>
+          </a:effectRef>
+          <a:fontRef idx="minor">
+            <a:schemeClr val="lt1"/>
+          </a:fontRef>
+        </p:style>
+        <p:txBody>
+          <a:bodyPr rtlCol="0" anchor="ctr"/>
+          <a:lstStyle/>
+          <a:p>
+            <a:pPr algn="ctr"/>
+          </a:p>
+        </p:txBody>
+      </p:sp>
+      <p:sp>
+        <p:nvSpPr>
+          <p:cNvPr id="30" name="Rounded Rectangle 29"/>
+          <p:cNvSpPr/>
+          <p:nvPr/>
+        </p:nvSpPr>
+        <p:spPr>
+          <a:xfrm>
+            <a:off x="749808" y="5605271"/>
+            <a:ext cx="493776" cy="475488"/>
+          </a:xfrm>
+          <a:prstGeom prst="roundRect">
+            <a:avLst>
+              <a:gd name="adj" fmla="val 10000"/>
+            </a:avLst>
+          </a:prstGeom>
+          <a:solidFill>
+            <a:srgbClr val="3B82F6"/>
+          </a:solidFill>
+          <a:ln>
+            <a:noFill/>
+          </a:ln>
+          <a:effectLst/>
+        </p:spPr>
+        <p:style>
+          <a:lnRef idx="1">
+            <a:schemeClr val="accent1"/>
+          </a:lnRef>
+          <a:fillRef idx="3">
+            <a:schemeClr val="accent1"/>
+          </a:fillRef>
+          <a:effectRef idx="2">
+            <a:schemeClr val="accent1"/>
+          </a:effectRef>
+          <a:fontRef idx="minor">
+            <a:schemeClr val="lt1"/>
+          </a:fontRef>
+        </p:style>
+        <p:txBody>
+          <a:bodyPr rtlCol="0" anchor="ctr"/>
+          <a:lstStyle/>
+          <a:p>
+            <a:pPr algn="ctr"/>
+          </a:p>
+        </p:txBody>
+      </p:sp>
+      <p:sp>
+        <p:nvSpPr>
+          <p:cNvPr id="31" name="TextBox 30"/>
+          <p:cNvSpPr txBox="1"/>
+          <p:nvPr/>
+        </p:nvSpPr>
+        <p:spPr>
+          <a:xfrm>
+            <a:off x="749808" y="5605271"/>
+            <a:ext cx="493776" cy="475488"/>
+          </a:xfrm>
+          <a:prstGeom prst="rect">
+            <a:avLst/>
+          </a:prstGeom>
+          <a:noFill/>
+        </p:spPr>
+        <p:txBody>
+          <a:bodyPr wrap="square" anchor="ctr" lIns="0" rIns="0" tIns="25400" bIns="25400">
+            <a:spAutoFit/>
+          </a:bodyPr>
+          <a:lstStyle/>
+          <a:p>
+            <a:pPr algn="ctr"/>
+            <a:r>
+              <a:rPr sz="1700" b="1" i="0">
+                <a:solidFill>
+                  <a:srgbClr val="FFFFFF"/>
+                </a:solidFill>
+                <a:latin typeface="Segoe UI"/>
+              </a:rPr>
+              <a:t>6</a:t>
+            </a:r>
+          </a:p>
+        </p:txBody>
+      </p:sp>
+      <p:sp>
+        <p:nvSpPr>
+          <p:cNvPr id="32" name="TextBox 31"/>
+          <p:cNvSpPr txBox="1"/>
+          <p:nvPr/>
+        </p:nvSpPr>
+        <p:spPr>
+          <a:xfrm>
+            <a:off x="1444752" y="5568695"/>
+            <a:ext cx="3977639" cy="512064"/>
+          </a:xfrm>
+          <a:prstGeom prst="rect">
+            <a:avLst/>
+          </a:prstGeom>
+          <a:noFill/>
+        </p:spPr>
+        <p:txBody>
+          <a:bodyPr wrap="square" anchor="ctr" lIns="0" rIns="0" tIns="25400" bIns="25400">
+            <a:spAutoFit/>
+          </a:bodyPr>
+          <a:lstStyle/>
+          <a:p>
+            <a:pPr algn="l"/>
+            <a:r>
+              <a:rPr sz="1520" b="1" i="0">
+                <a:solidFill>
+                  <a:srgbClr val="1D4ED8"/>
+                </a:solidFill>
+                <a:latin typeface="Segoe UI"/>
+              </a:rPr>
+              <a:t>Official test supports 4/5 contrasts</a:t>
+            </a:r>
+          </a:p>
+        </p:txBody>
+      </p:sp>
+      <p:sp>
+        <p:nvSpPr>
+          <p:cNvPr id="33" name="TextBox 32"/>
+          <p:cNvSpPr txBox="1"/>
+          <p:nvPr/>
+        </p:nvSpPr>
+        <p:spPr>
+          <a:xfrm>
+            <a:off x="5504688" y="5568695"/>
+            <a:ext cx="5669280" cy="512064"/>
+          </a:xfrm>
+          <a:prstGeom prst="rect">
+            <a:avLst/>
+          </a:prstGeom>
+          <a:noFill/>
+        </p:spPr>
+        <p:txBody>
+          <a:bodyPr wrap="square" anchor="ctr" lIns="0" rIns="0" tIns="25400" bIns="25400">
+            <a:spAutoFit/>
+          </a:bodyPr>
+          <a:lstStyle/>
+          <a:p>
+            <a:pPr algn="l"/>
+            <a:r>
+              <a:rPr sz="1280" b="0" i="0">
+                <a:solidFill>
+                  <a:srgbClr val="334155"/>
+                </a:solidFill>
+                <a:latin typeface="Segoe UI"/>
+              </a:rPr>
+              <a:t>zho is inconclusive; no main system exceeds the leaderboard best.</a:t>
             </a:r>
           </a:p>
         </p:txBody>

</xml_diff>